<commit_message>
Demographic indicators slide updated for Velikiy Novgorod forecast slide
Co-Authored-By: Claude Sonnet 5.5 <noreply@anthropic.com>
Claude-Session: https://claude.ai/code/session_01PfagTkBBfn3ShTm5bX9M45
</commit_message>
<xml_diff>
--- a/slide_pokazateli_demografiya.pptx
+++ b/slide_pokazateli_demografiya.pptx
@@ -430,7 +430,7 @@
           <a:lstStyle/>
           <a:p>
             <a:r>
-              <a:t>Единый перечень составлен по содержимому слайдов 22 и 23 презентации (динамика населения и половозрастная структура), без привязки к конкретным слайдам. Источники данных в презентации для этих примеров указаны на самих слайдах (Новгородстат, Башкортостанстат), поэтому отдельной колонки нет.</a:t>
+              <a:t>Единый перечень составлен по содержимому слайдов 22 и 23 презентации (демографический прогноз Великого Новгорода с суммарным коэффициентом рождаемости и половозрастная структура), без привязки к конкретным слайдам. Источники данных в презентации для этих примеров указаны на самих слайдах (Новгородстат, Башкортостанстат), поэтому отдельной колонки нет.</a:t>
             </a:r>
           </a:p>
         </p:txBody>
@@ -6432,7 +6432,7 @@
         <p:spPr>
           <a:xfrm>
             <a:off x="1417320" y="2624328"/>
-            <a:ext cx="6766560" cy="822960"/>
+            <a:ext cx="6766560" cy="640080"/>
           </a:xfrm>
           <a:prstGeom prst="rect">
             <a:avLst/>
@@ -6446,7 +6446,7 @@
           <a:lstStyle/>
           <a:p>
             <a:r>
-              <a:rPr sz="1700" b="1">
+              <a:rPr sz="1600" b="1">
                 <a:solidFill>
                   <a:srgbClr val="062D3F"/>
                 </a:solidFill>
@@ -6466,7 +6466,7 @@
         <p:spPr>
           <a:xfrm>
             <a:off x="8412480" y="2624328"/>
-            <a:ext cx="3566160" cy="822960"/>
+            <a:ext cx="3566160" cy="640080"/>
           </a:xfrm>
           <a:prstGeom prst="rect">
             <a:avLst/>
@@ -6500,7 +6500,7 @@
         <p:spPr>
           <a:xfrm>
             <a:off x="12252960" y="2624328"/>
-            <a:ext cx="5303520" cy="822960"/>
+            <a:ext cx="5303520" cy="640080"/>
           </a:xfrm>
           <a:prstGeom prst="rect">
             <a:avLst/>
@@ -6520,7 +6520,7 @@
                 </a:solidFill>
                 <a:latin typeface="Circe"/>
               </a:rPr>
-              <a:t>Значение на начало года и прогноз по сценариям</a:t>
+              <a:t>Динамика и прогноз по четырём сценариям</a:t>
             </a:r>
           </a:p>
         </p:txBody>
@@ -6533,7 +6533,7 @@
         </p:nvCxnSpPr>
         <p:spPr>
           <a:xfrm>
-            <a:off x="1069848" y="3447288"/>
+            <a:off x="1069848" y="3264408"/>
             <a:ext cx="16870679" cy="0"/>
           </a:xfrm>
           <a:prstGeom prst="line">
@@ -6554,8 +6554,8 @@
         </p:nvSpPr>
         <p:spPr>
           <a:xfrm>
-            <a:off x="1417320" y="3447288"/>
-            <a:ext cx="6766560" cy="822960"/>
+            <a:off x="1417320" y="3264408"/>
+            <a:ext cx="6766560" cy="640080"/>
           </a:xfrm>
           <a:prstGeom prst="rect">
             <a:avLst/>
@@ -6569,13 +6569,13 @@
           <a:lstStyle/>
           <a:p>
             <a:r>
-              <a:rPr sz="1700" b="1">
+              <a:rPr sz="1600" b="1">
                 <a:solidFill>
                   <a:srgbClr val="062D3F"/>
                 </a:solidFill>
                 <a:latin typeface="Circe Bold"/>
               </a:rPr>
-              <a:t>Среднегодовой миграционный прирост</a:t>
+              <a:t>Среднегодовая численность населения</a:t>
             </a:r>
           </a:p>
         </p:txBody>
@@ -6588,8 +6588,8 @@
         </p:nvSpPr>
         <p:spPr>
           <a:xfrm>
-            <a:off x="8412480" y="3447288"/>
-            <a:ext cx="3566160" cy="822960"/>
+            <a:off x="8412480" y="3264408"/>
+            <a:ext cx="3566160" cy="640080"/>
           </a:xfrm>
           <a:prstGeom prst="rect">
             <a:avLst/>
@@ -6622,8 +6622,131 @@
         </p:nvSpPr>
         <p:spPr>
           <a:xfrm>
-            <a:off x="12252960" y="3447288"/>
-            <a:ext cx="5303520" cy="822960"/>
+            <a:off x="12252960" y="3264408"/>
+            <a:ext cx="5303520" cy="640080"/>
+          </a:xfrm>
+          <a:prstGeom prst="rect">
+            <a:avLst/>
+          </a:prstGeom>
+          <a:noFill/>
+        </p:spPr>
+        <p:txBody>
+          <a:bodyPr wrap="square" anchor="ctr" lIns="0" rIns="0" tIns="0" bIns="0">
+            <a:spAutoFit/>
+          </a:bodyPr>
+          <a:lstStyle/>
+          <a:p>
+            <a:r>
+              <a:rPr sz="1600" b="0">
+                <a:solidFill>
+                  <a:srgbClr val="062D3F"/>
+                </a:solidFill>
+                <a:latin typeface="Circe"/>
+              </a:rPr>
+              <a:t>Факт и целевые показатели стратегии</a:t>
+            </a:r>
+          </a:p>
+        </p:txBody>
+      </p:sp>
+      <p:cxnSp>
+        <p:nvCxnSpPr>
+          <p:cNvPr id="214" name="Разделитель"/>
+          <p:cNvCxnSpPr/>
+          <p:nvPr/>
+        </p:nvCxnSpPr>
+        <p:spPr>
+          <a:xfrm>
+            <a:off x="1069848" y="3904488"/>
+            <a:ext cx="16870679" cy="0"/>
+          </a:xfrm>
+          <a:prstGeom prst="line">
+            <a:avLst/>
+          </a:prstGeom>
+          <a:ln w="12700">
+            <a:solidFill>
+              <a:srgbClr val="D9DEE2"/>
+            </a:solidFill>
+          </a:ln>
+        </p:spPr>
+      </p:cxnSp>
+      <p:sp>
+        <p:nvSpPr>
+          <p:cNvPr id="215" name="Текст"/>
+          <p:cNvSpPr txBox="1"/>
+          <p:nvPr/>
+        </p:nvSpPr>
+        <p:spPr>
+          <a:xfrm>
+            <a:off x="1417320" y="3904488"/>
+            <a:ext cx="6766560" cy="640080"/>
+          </a:xfrm>
+          <a:prstGeom prst="rect">
+            <a:avLst/>
+          </a:prstGeom>
+          <a:noFill/>
+        </p:spPr>
+        <p:txBody>
+          <a:bodyPr wrap="square" anchor="ctr" lIns="0" rIns="0" tIns="0" bIns="0">
+            <a:spAutoFit/>
+          </a:bodyPr>
+          <a:lstStyle/>
+          <a:p>
+            <a:r>
+              <a:rPr sz="1600" b="1">
+                <a:solidFill>
+                  <a:srgbClr val="062D3F"/>
+                </a:solidFill>
+                <a:latin typeface="Circe Bold"/>
+              </a:rPr>
+              <a:t>Суммарный коэффициент рождаемости</a:t>
+            </a:r>
+          </a:p>
+        </p:txBody>
+      </p:sp>
+      <p:sp>
+        <p:nvSpPr>
+          <p:cNvPr id="216" name="Текст"/>
+          <p:cNvSpPr txBox="1"/>
+          <p:nvPr/>
+        </p:nvSpPr>
+        <p:spPr>
+          <a:xfrm>
+            <a:off x="8412480" y="3904488"/>
+            <a:ext cx="3566160" cy="640080"/>
+          </a:xfrm>
+          <a:prstGeom prst="rect">
+            <a:avLst/>
+          </a:prstGeom>
+          <a:noFill/>
+        </p:spPr>
+        <p:txBody>
+          <a:bodyPr wrap="square" anchor="ctr" lIns="0" rIns="0" tIns="0" bIns="0">
+            <a:spAutoFit/>
+          </a:bodyPr>
+          <a:lstStyle/>
+          <a:p>
+            <a:r>
+              <a:rPr sz="1600" b="0">
+                <a:solidFill>
+                  <a:srgbClr val="5E6B73"/>
+                </a:solidFill>
+                <a:latin typeface="Circe"/>
+              </a:rPr>
+              <a:t>детей на 1 женщину</a:t>
+            </a:r>
+          </a:p>
+        </p:txBody>
+      </p:sp>
+      <p:sp>
+        <p:nvSpPr>
+          <p:cNvPr id="217" name="Текст"/>
+          <p:cNvSpPr txBox="1"/>
+          <p:nvPr/>
+        </p:nvSpPr>
+        <p:spPr>
+          <a:xfrm>
+            <a:off x="12252960" y="3904488"/>
+            <a:ext cx="5303520" cy="640080"/>
           </a:xfrm>
           <a:prstGeom prst="rect">
             <a:avLst/>
@@ -6650,13 +6773,13 @@
       </p:sp>
       <p:cxnSp>
         <p:nvCxnSpPr>
-          <p:cNvPr id="214" name="Разделитель"/>
+          <p:cNvPr id="218" name="Разделитель"/>
           <p:cNvCxnSpPr/>
           <p:nvPr/>
         </p:nvCxnSpPr>
         <p:spPr>
           <a:xfrm>
-            <a:off x="1069848" y="4270248"/>
+            <a:off x="1069848" y="4544568"/>
             <a:ext cx="16870679" cy="0"/>
           </a:xfrm>
           <a:prstGeom prst="line">
@@ -6671,14 +6794,14 @@
       </p:cxnSp>
       <p:sp>
         <p:nvSpPr>
-          <p:cNvPr id="215" name="Текст"/>
+          <p:cNvPr id="219" name="Текст"/>
           <p:cNvSpPr txBox="1"/>
           <p:nvPr/>
         </p:nvSpPr>
         <p:spPr>
           <a:xfrm>
-            <a:off x="1417320" y="4270248"/>
-            <a:ext cx="6766560" cy="822960"/>
+            <a:off x="1417320" y="4544568"/>
+            <a:ext cx="6766560" cy="640080"/>
           </a:xfrm>
           <a:prstGeom prst="rect">
             <a:avLst/>
@@ -6692,27 +6815,27 @@
           <a:lstStyle/>
           <a:p>
             <a:r>
-              <a:rPr sz="1700" b="1">
+              <a:rPr sz="1600" b="1">
                 <a:solidFill>
                   <a:srgbClr val="062D3F"/>
                 </a:solidFill>
                 <a:latin typeface="Circe Bold"/>
               </a:rPr>
-              <a:t>Суммарный коэффициент рождаемости</a:t>
+              <a:t>Среднегодовой миграционный прирост</a:t>
             </a:r>
           </a:p>
         </p:txBody>
       </p:sp>
       <p:sp>
         <p:nvSpPr>
-          <p:cNvPr id="216" name="Текст"/>
+          <p:cNvPr id="220" name="Текст"/>
           <p:cNvSpPr txBox="1"/>
           <p:nvPr/>
         </p:nvSpPr>
         <p:spPr>
           <a:xfrm>
-            <a:off x="8412480" y="4270248"/>
-            <a:ext cx="3566160" cy="822960"/>
+            <a:off x="8412480" y="4544568"/>
+            <a:ext cx="3566160" cy="640080"/>
           </a:xfrm>
           <a:prstGeom prst="rect">
             <a:avLst/>
@@ -6732,21 +6855,21 @@
                 </a:solidFill>
                 <a:latin typeface="Circe"/>
               </a:rPr>
-              <a:t>детей на 1 женщину</a:t>
+              <a:t>тыс. чел.</a:t>
             </a:r>
           </a:p>
         </p:txBody>
       </p:sp>
       <p:sp>
         <p:nvSpPr>
-          <p:cNvPr id="217" name="Текст"/>
+          <p:cNvPr id="221" name="Текст"/>
           <p:cNvSpPr txBox="1"/>
           <p:nvPr/>
         </p:nvSpPr>
         <p:spPr>
           <a:xfrm>
-            <a:off x="12252960" y="4270248"/>
-            <a:ext cx="5303520" cy="822960"/>
+            <a:off x="12252960" y="4544568"/>
+            <a:ext cx="5303520" cy="640080"/>
           </a:xfrm>
           <a:prstGeom prst="rect">
             <a:avLst/>
@@ -6766,20 +6889,20 @@
                 </a:solidFill>
                 <a:latin typeface="Circe"/>
               </a:rPr>
-              <a:t>Целевой показатель прогноза</a:t>
+              <a:t>Основа сценариев прогноза</a:t>
             </a:r>
           </a:p>
         </p:txBody>
       </p:sp>
       <p:cxnSp>
         <p:nvCxnSpPr>
-          <p:cNvPr id="218" name="Разделитель"/>
+          <p:cNvPr id="222" name="Разделитель"/>
           <p:cNvCxnSpPr/>
           <p:nvPr/>
         </p:nvCxnSpPr>
         <p:spPr>
           <a:xfrm>
-            <a:off x="1069848" y="5093208"/>
+            <a:off x="1069848" y="5184648"/>
             <a:ext cx="16870679" cy="0"/>
           </a:xfrm>
           <a:prstGeom prst="line">
@@ -6794,14 +6917,14 @@
       </p:cxnSp>
       <p:sp>
         <p:nvSpPr>
-          <p:cNvPr id="219" name="Текст"/>
+          <p:cNvPr id="223" name="Текст"/>
           <p:cNvSpPr txBox="1"/>
           <p:nvPr/>
         </p:nvSpPr>
         <p:spPr>
           <a:xfrm>
-            <a:off x="1417320" y="5093208"/>
-            <a:ext cx="6766560" cy="822960"/>
+            <a:off x="1417320" y="5184648"/>
+            <a:ext cx="6766560" cy="640080"/>
           </a:xfrm>
           <a:prstGeom prst="rect">
             <a:avLst/>
@@ -6815,27 +6938,27 @@
           <a:lstStyle/>
           <a:p>
             <a:r>
-              <a:rPr sz="1700" b="1">
+              <a:rPr sz="1600" b="1">
                 <a:solidFill>
                   <a:srgbClr val="062D3F"/>
                 </a:solidFill>
                 <a:latin typeface="Circe Bold"/>
               </a:rPr>
-              <a:t>Ожидаемая продолжительность жизни</a:t>
+              <a:t>Общий коэффициент рождаемости</a:t>
             </a:r>
           </a:p>
         </p:txBody>
       </p:sp>
       <p:sp>
         <p:nvSpPr>
-          <p:cNvPr id="220" name="Текст"/>
+          <p:cNvPr id="224" name="Текст"/>
           <p:cNvSpPr txBox="1"/>
           <p:nvPr/>
         </p:nvSpPr>
         <p:spPr>
           <a:xfrm>
-            <a:off x="8412480" y="5093208"/>
-            <a:ext cx="3566160" cy="822960"/>
+            <a:off x="8412480" y="5184648"/>
+            <a:ext cx="3566160" cy="640080"/>
           </a:xfrm>
           <a:prstGeom prst="rect">
             <a:avLst/>
@@ -6855,21 +6978,21 @@
                 </a:solidFill>
                 <a:latin typeface="Circe"/>
               </a:rPr>
-              <a:t>лет, мужчины и женщины</a:t>
+              <a:t>родившихся на 1000 населения</a:t>
             </a:r>
           </a:p>
         </p:txBody>
       </p:sp>
       <p:sp>
         <p:nvSpPr>
-          <p:cNvPr id="221" name="Текст"/>
+          <p:cNvPr id="225" name="Текст"/>
           <p:cNvSpPr txBox="1"/>
           <p:nvPr/>
         </p:nvSpPr>
         <p:spPr>
           <a:xfrm>
-            <a:off x="12252960" y="5093208"/>
-            <a:ext cx="5303520" cy="822960"/>
+            <a:off x="12252960" y="5184648"/>
+            <a:ext cx="5303520" cy="640080"/>
           </a:xfrm>
           <a:prstGeom prst="rect">
             <a:avLst/>
@@ -6889,20 +7012,20 @@
                 </a:solidFill>
                 <a:latin typeface="Circe"/>
               </a:rPr>
-              <a:t>Целевой показатель прогноза</a:t>
+              <a:t>Факт и целевые показатели стратегии</a:t>
             </a:r>
           </a:p>
         </p:txBody>
       </p:sp>
       <p:cxnSp>
         <p:nvCxnSpPr>
-          <p:cNvPr id="222" name="Разделитель"/>
+          <p:cNvPr id="226" name="Разделитель"/>
           <p:cNvCxnSpPr/>
           <p:nvPr/>
         </p:nvCxnSpPr>
         <p:spPr>
           <a:xfrm>
-            <a:off x="1069848" y="5916168"/>
+            <a:off x="1069848" y="5824728"/>
             <a:ext cx="16870679" cy="0"/>
           </a:xfrm>
           <a:prstGeom prst="line">
@@ -6917,14 +7040,14 @@
       </p:cxnSp>
       <p:sp>
         <p:nvSpPr>
-          <p:cNvPr id="223" name="Текст"/>
+          <p:cNvPr id="227" name="Текст"/>
           <p:cNvSpPr txBox="1"/>
           <p:nvPr/>
         </p:nvSpPr>
         <p:spPr>
           <a:xfrm>
-            <a:off x="1417320" y="5916168"/>
-            <a:ext cx="6766560" cy="822960"/>
+            <a:off x="1417320" y="5824728"/>
+            <a:ext cx="6766560" cy="640080"/>
           </a:xfrm>
           <a:prstGeom prst="rect">
             <a:avLst/>
@@ -6938,27 +7061,27 @@
           <a:lstStyle/>
           <a:p>
             <a:r>
-              <a:rPr sz="1700" b="1">
+              <a:rPr sz="1600" b="1">
                 <a:solidFill>
                   <a:srgbClr val="062D3F"/>
                 </a:solidFill>
                 <a:latin typeface="Circe Bold"/>
               </a:rPr>
-              <a:t>Смертность</a:t>
+              <a:t>Общий коэффициент смертности</a:t>
             </a:r>
           </a:p>
         </p:txBody>
       </p:sp>
       <p:sp>
         <p:nvSpPr>
-          <p:cNvPr id="224" name="Текст"/>
+          <p:cNvPr id="228" name="Текст"/>
           <p:cNvSpPr txBox="1"/>
           <p:nvPr/>
         </p:nvSpPr>
         <p:spPr>
           <a:xfrm>
-            <a:off x="8412480" y="5916168"/>
-            <a:ext cx="3566160" cy="822960"/>
+            <a:off x="8412480" y="5824728"/>
+            <a:ext cx="3566160" cy="640080"/>
           </a:xfrm>
           <a:prstGeom prst="rect">
             <a:avLst/>
@@ -6978,21 +7101,21 @@
                 </a:solidFill>
                 <a:latin typeface="Circe"/>
               </a:rPr>
-              <a:t>умерших на 1000 жителей</a:t>
+              <a:t>умерших на 1000 населения</a:t>
             </a:r>
           </a:p>
         </p:txBody>
       </p:sp>
       <p:sp>
         <p:nvSpPr>
-          <p:cNvPr id="225" name="Текст"/>
+          <p:cNvPr id="229" name="Текст"/>
           <p:cNvSpPr txBox="1"/>
           <p:nvPr/>
         </p:nvSpPr>
         <p:spPr>
           <a:xfrm>
-            <a:off x="12252960" y="5916168"/>
-            <a:ext cx="5303520" cy="822960"/>
+            <a:off x="12252960" y="5824728"/>
+            <a:ext cx="5303520" cy="640080"/>
           </a:xfrm>
           <a:prstGeom prst="rect">
             <a:avLst/>
@@ -7012,20 +7135,20 @@
                 </a:solidFill>
                 <a:latin typeface="Circe"/>
               </a:rPr>
-              <a:t>Целевая задача прогноза</a:t>
+              <a:t>Факт и целевые показатели стратегии</a:t>
             </a:r>
           </a:p>
         </p:txBody>
       </p:sp>
       <p:cxnSp>
         <p:nvCxnSpPr>
-          <p:cNvPr id="226" name="Разделитель"/>
+          <p:cNvPr id="230" name="Разделитель"/>
           <p:cNvCxnSpPr/>
           <p:nvPr/>
         </p:nvCxnSpPr>
         <p:spPr>
           <a:xfrm>
-            <a:off x="1069848" y="6739128"/>
+            <a:off x="1069848" y="6464808"/>
             <a:ext cx="16870679" cy="0"/>
           </a:xfrm>
           <a:prstGeom prst="line">
@@ -7040,14 +7163,14 @@
       </p:cxnSp>
       <p:sp>
         <p:nvSpPr>
-          <p:cNvPr id="227" name="Текст"/>
+          <p:cNvPr id="231" name="Текст"/>
           <p:cNvSpPr txBox="1"/>
           <p:nvPr/>
         </p:nvSpPr>
         <p:spPr>
           <a:xfrm>
-            <a:off x="1417320" y="6739128"/>
-            <a:ext cx="6766560" cy="822960"/>
+            <a:off x="1417320" y="6464808"/>
+            <a:ext cx="6766560" cy="640080"/>
           </a:xfrm>
           <a:prstGeom prst="rect">
             <a:avLst/>
@@ -7061,7 +7184,253 @@
           <a:lstStyle/>
           <a:p>
             <a:r>
-              <a:rPr sz="1700" b="1">
+              <a:rPr sz="1600" b="1">
+                <a:solidFill>
+                  <a:srgbClr val="062D3F"/>
+                </a:solidFill>
+                <a:latin typeface="Circe Bold"/>
+              </a:rPr>
+              <a:t>Коэффициент естественного прироста</a:t>
+            </a:r>
+          </a:p>
+        </p:txBody>
+      </p:sp>
+      <p:sp>
+        <p:nvSpPr>
+          <p:cNvPr id="232" name="Текст"/>
+          <p:cNvSpPr txBox="1"/>
+          <p:nvPr/>
+        </p:nvSpPr>
+        <p:spPr>
+          <a:xfrm>
+            <a:off x="8412480" y="6464808"/>
+            <a:ext cx="3566160" cy="640080"/>
+          </a:xfrm>
+          <a:prstGeom prst="rect">
+            <a:avLst/>
+          </a:prstGeom>
+          <a:noFill/>
+        </p:spPr>
+        <p:txBody>
+          <a:bodyPr wrap="square" anchor="ctr" lIns="0" rIns="0" tIns="0" bIns="0">
+            <a:spAutoFit/>
+          </a:bodyPr>
+          <a:lstStyle/>
+          <a:p>
+            <a:r>
+              <a:rPr sz="1600" b="0">
+                <a:solidFill>
+                  <a:srgbClr val="5E6B73"/>
+                </a:solidFill>
+                <a:latin typeface="Circe"/>
+              </a:rPr>
+              <a:t>на 1000 населения</a:t>
+            </a:r>
+          </a:p>
+        </p:txBody>
+      </p:sp>
+      <p:sp>
+        <p:nvSpPr>
+          <p:cNvPr id="233" name="Текст"/>
+          <p:cNvSpPr txBox="1"/>
+          <p:nvPr/>
+        </p:nvSpPr>
+        <p:spPr>
+          <a:xfrm>
+            <a:off x="12252960" y="6464808"/>
+            <a:ext cx="5303520" cy="640080"/>
+          </a:xfrm>
+          <a:prstGeom prst="rect">
+            <a:avLst/>
+          </a:prstGeom>
+          <a:noFill/>
+        </p:spPr>
+        <p:txBody>
+          <a:bodyPr wrap="square" anchor="ctr" lIns="0" rIns="0" tIns="0" bIns="0">
+            <a:spAutoFit/>
+          </a:bodyPr>
+          <a:lstStyle/>
+          <a:p>
+            <a:r>
+              <a:rPr sz="1600" b="0">
+                <a:solidFill>
+                  <a:srgbClr val="062D3F"/>
+                </a:solidFill>
+                <a:latin typeface="Circe"/>
+              </a:rPr>
+              <a:t>Факт и целевые показатели стратегии</a:t>
+            </a:r>
+          </a:p>
+        </p:txBody>
+      </p:sp>
+      <p:cxnSp>
+        <p:nvCxnSpPr>
+          <p:cNvPr id="234" name="Разделитель"/>
+          <p:cNvCxnSpPr/>
+          <p:nvPr/>
+        </p:nvCxnSpPr>
+        <p:spPr>
+          <a:xfrm>
+            <a:off x="1069848" y="7104888"/>
+            <a:ext cx="16870679" cy="0"/>
+          </a:xfrm>
+          <a:prstGeom prst="line">
+            <a:avLst/>
+          </a:prstGeom>
+          <a:ln w="12700">
+            <a:solidFill>
+              <a:srgbClr val="D9DEE2"/>
+            </a:solidFill>
+          </a:ln>
+        </p:spPr>
+      </p:cxnSp>
+      <p:sp>
+        <p:nvSpPr>
+          <p:cNvPr id="235" name="Текст"/>
+          <p:cNvSpPr txBox="1"/>
+          <p:nvPr/>
+        </p:nvSpPr>
+        <p:spPr>
+          <a:xfrm>
+            <a:off x="1417320" y="7104888"/>
+            <a:ext cx="6766560" cy="640080"/>
+          </a:xfrm>
+          <a:prstGeom prst="rect">
+            <a:avLst/>
+          </a:prstGeom>
+          <a:noFill/>
+        </p:spPr>
+        <p:txBody>
+          <a:bodyPr wrap="square" anchor="ctr" lIns="0" rIns="0" tIns="0" bIns="0">
+            <a:spAutoFit/>
+          </a:bodyPr>
+          <a:lstStyle/>
+          <a:p>
+            <a:r>
+              <a:rPr sz="1600" b="1">
+                <a:solidFill>
+                  <a:srgbClr val="062D3F"/>
+                </a:solidFill>
+                <a:latin typeface="Circe Bold"/>
+              </a:rPr>
+              <a:t>Коэффициент миграционного прироста</a:t>
+            </a:r>
+          </a:p>
+        </p:txBody>
+      </p:sp>
+      <p:sp>
+        <p:nvSpPr>
+          <p:cNvPr id="236" name="Текст"/>
+          <p:cNvSpPr txBox="1"/>
+          <p:nvPr/>
+        </p:nvSpPr>
+        <p:spPr>
+          <a:xfrm>
+            <a:off x="8412480" y="7104888"/>
+            <a:ext cx="3566160" cy="640080"/>
+          </a:xfrm>
+          <a:prstGeom prst="rect">
+            <a:avLst/>
+          </a:prstGeom>
+          <a:noFill/>
+        </p:spPr>
+        <p:txBody>
+          <a:bodyPr wrap="square" anchor="ctr" lIns="0" rIns="0" tIns="0" bIns="0">
+            <a:spAutoFit/>
+          </a:bodyPr>
+          <a:lstStyle/>
+          <a:p>
+            <a:r>
+              <a:rPr sz="1600" b="0">
+                <a:solidFill>
+                  <a:srgbClr val="5E6B73"/>
+                </a:solidFill>
+                <a:latin typeface="Circe"/>
+              </a:rPr>
+              <a:t>на 1000 населения</a:t>
+            </a:r>
+          </a:p>
+        </p:txBody>
+      </p:sp>
+      <p:sp>
+        <p:nvSpPr>
+          <p:cNvPr id="237" name="Текст"/>
+          <p:cNvSpPr txBox="1"/>
+          <p:nvPr/>
+        </p:nvSpPr>
+        <p:spPr>
+          <a:xfrm>
+            <a:off x="12252960" y="7104888"/>
+            <a:ext cx="5303520" cy="640080"/>
+          </a:xfrm>
+          <a:prstGeom prst="rect">
+            <a:avLst/>
+          </a:prstGeom>
+          <a:noFill/>
+        </p:spPr>
+        <p:txBody>
+          <a:bodyPr wrap="square" anchor="ctr" lIns="0" rIns="0" tIns="0" bIns="0">
+            <a:spAutoFit/>
+          </a:bodyPr>
+          <a:lstStyle/>
+          <a:p>
+            <a:r>
+              <a:rPr sz="1600" b="0">
+                <a:solidFill>
+                  <a:srgbClr val="062D3F"/>
+                </a:solidFill>
+                <a:latin typeface="Circe"/>
+              </a:rPr>
+              <a:t>Факт и целевые показатели стратегии</a:t>
+            </a:r>
+          </a:p>
+        </p:txBody>
+      </p:sp>
+      <p:cxnSp>
+        <p:nvCxnSpPr>
+          <p:cNvPr id="238" name="Разделитель"/>
+          <p:cNvCxnSpPr/>
+          <p:nvPr/>
+        </p:nvCxnSpPr>
+        <p:spPr>
+          <a:xfrm>
+            <a:off x="1069848" y="7744968"/>
+            <a:ext cx="16870679" cy="0"/>
+          </a:xfrm>
+          <a:prstGeom prst="line">
+            <a:avLst/>
+          </a:prstGeom>
+          <a:ln w="12700">
+            <a:solidFill>
+              <a:srgbClr val="D9DEE2"/>
+            </a:solidFill>
+          </a:ln>
+        </p:spPr>
+      </p:cxnSp>
+      <p:sp>
+        <p:nvSpPr>
+          <p:cNvPr id="239" name="Текст"/>
+          <p:cNvSpPr txBox="1"/>
+          <p:nvPr/>
+        </p:nvSpPr>
+        <p:spPr>
+          <a:xfrm>
+            <a:off x="1417320" y="7744968"/>
+            <a:ext cx="6766560" cy="640080"/>
+          </a:xfrm>
+          <a:prstGeom prst="rect">
+            <a:avLst/>
+          </a:prstGeom>
+          <a:noFill/>
+        </p:spPr>
+        <p:txBody>
+          <a:bodyPr wrap="square" anchor="ctr" lIns="0" rIns="0" tIns="0" bIns="0">
+            <a:spAutoFit/>
+          </a:bodyPr>
+          <a:lstStyle/>
+          <a:p>
+            <a:r>
+              <a:rPr sz="1600" b="1">
                 <a:solidFill>
                   <a:srgbClr val="062D3F"/>
                 </a:solidFill>
@@ -7074,14 +7443,14 @@
       </p:sp>
       <p:sp>
         <p:nvSpPr>
-          <p:cNvPr id="228" name="Текст"/>
+          <p:cNvPr id="240" name="Текст"/>
           <p:cNvSpPr txBox="1"/>
           <p:nvPr/>
         </p:nvSpPr>
         <p:spPr>
           <a:xfrm>
-            <a:off x="8412480" y="6739128"/>
-            <a:ext cx="3566160" cy="822960"/>
+            <a:off x="8412480" y="7744968"/>
+            <a:ext cx="3566160" cy="640080"/>
           </a:xfrm>
           <a:prstGeom prst="rect">
             <a:avLst/>
@@ -7108,14 +7477,14 @@
       </p:sp>
       <p:sp>
         <p:nvSpPr>
-          <p:cNvPr id="229" name="Текст"/>
+          <p:cNvPr id="241" name="Текст"/>
           <p:cNvSpPr txBox="1"/>
           <p:nvPr/>
         </p:nvSpPr>
         <p:spPr>
           <a:xfrm>
-            <a:off x="12252960" y="6739128"/>
-            <a:ext cx="5303520" cy="822960"/>
+            <a:off x="12252960" y="7744968"/>
+            <a:ext cx="5303520" cy="640080"/>
           </a:xfrm>
           <a:prstGeom prst="rect">
             <a:avLst/>
@@ -7142,13 +7511,13 @@
       </p:sp>
       <p:cxnSp>
         <p:nvCxnSpPr>
-          <p:cNvPr id="230" name="Разделитель"/>
+          <p:cNvPr id="242" name="Разделитель"/>
           <p:cNvCxnSpPr/>
           <p:nvPr/>
         </p:nvCxnSpPr>
         <p:spPr>
           <a:xfrm>
-            <a:off x="1069848" y="7562088"/>
+            <a:off x="1069848" y="8385048"/>
             <a:ext cx="16870679" cy="0"/>
           </a:xfrm>
           <a:prstGeom prst="line">
@@ -7163,14 +7532,14 @@
       </p:cxnSp>
       <p:sp>
         <p:nvSpPr>
-          <p:cNvPr id="231" name="Текст"/>
+          <p:cNvPr id="243" name="Текст"/>
           <p:cNvSpPr txBox="1"/>
           <p:nvPr/>
         </p:nvSpPr>
         <p:spPr>
           <a:xfrm>
-            <a:off x="1417320" y="7562088"/>
-            <a:ext cx="6766560" cy="822960"/>
+            <a:off x="1417320" y="8385048"/>
+            <a:ext cx="6766560" cy="640080"/>
           </a:xfrm>
           <a:prstGeom prst="rect">
             <a:avLst/>
@@ -7184,7 +7553,7 @@
           <a:lstStyle/>
           <a:p>
             <a:r>
-              <a:rPr sz="1700" b="1">
+              <a:rPr sz="1600" b="1">
                 <a:solidFill>
                   <a:srgbClr val="062D3F"/>
                 </a:solidFill>
@@ -7197,14 +7566,14 @@
       </p:sp>
       <p:sp>
         <p:nvSpPr>
-          <p:cNvPr id="232" name="Текст"/>
+          <p:cNvPr id="244" name="Текст"/>
           <p:cNvSpPr txBox="1"/>
           <p:nvPr/>
         </p:nvSpPr>
         <p:spPr>
           <a:xfrm>
-            <a:off x="8412480" y="7562088"/>
-            <a:ext cx="3566160" cy="822960"/>
+            <a:off x="8412480" y="8385048"/>
+            <a:ext cx="3566160" cy="640080"/>
           </a:xfrm>
           <a:prstGeom prst="rect">
             <a:avLst/>
@@ -7231,14 +7600,14 @@
       </p:sp>
       <p:sp>
         <p:nvSpPr>
-          <p:cNvPr id="233" name="Текст"/>
+          <p:cNvPr id="245" name="Текст"/>
           <p:cNvSpPr txBox="1"/>
           <p:nvPr/>
         </p:nvSpPr>
         <p:spPr>
           <a:xfrm>
-            <a:off x="12252960" y="7562088"/>
-            <a:ext cx="5303520" cy="822960"/>
+            <a:off x="12252960" y="8385048"/>
+            <a:ext cx="5303520" cy="640080"/>
           </a:xfrm>
           <a:prstGeom prst="rect">
             <a:avLst/>
@@ -7265,13 +7634,13 @@
       </p:sp>
       <p:cxnSp>
         <p:nvCxnSpPr>
-          <p:cNvPr id="234" name="Разделитель"/>
+          <p:cNvPr id="246" name="Разделитель"/>
           <p:cNvCxnSpPr/>
           <p:nvPr/>
         </p:nvCxnSpPr>
         <p:spPr>
           <a:xfrm>
-            <a:off x="1069848" y="8385048"/>
+            <a:off x="1069848" y="9025128"/>
             <a:ext cx="16870679" cy="0"/>
           </a:xfrm>
           <a:prstGeom prst="line">
@@ -7286,14 +7655,14 @@
       </p:cxnSp>
       <p:sp>
         <p:nvSpPr>
-          <p:cNvPr id="235" name="Текст"/>
+          <p:cNvPr id="247" name="Текст"/>
           <p:cNvSpPr txBox="1"/>
           <p:nvPr/>
         </p:nvSpPr>
         <p:spPr>
           <a:xfrm>
-            <a:off x="1417320" y="8385048"/>
-            <a:ext cx="6766560" cy="822960"/>
+            <a:off x="1417320" y="9025128"/>
+            <a:ext cx="6766560" cy="640080"/>
           </a:xfrm>
           <a:prstGeom prst="rect">
             <a:avLst/>
@@ -7307,7 +7676,7 @@
           <a:lstStyle/>
           <a:p>
             <a:r>
-              <a:rPr sz="1700" b="1">
+              <a:rPr sz="1600" b="1">
                 <a:solidFill>
                   <a:srgbClr val="062D3F"/>
                 </a:solidFill>
@@ -7320,14 +7689,14 @@
       </p:sp>
       <p:sp>
         <p:nvSpPr>
-          <p:cNvPr id="236" name="Текст"/>
+          <p:cNvPr id="248" name="Текст"/>
           <p:cNvSpPr txBox="1"/>
           <p:nvPr/>
         </p:nvSpPr>
         <p:spPr>
           <a:xfrm>
-            <a:off x="8412480" y="8385048"/>
-            <a:ext cx="3566160" cy="822960"/>
+            <a:off x="8412480" y="9025128"/>
+            <a:ext cx="3566160" cy="640080"/>
           </a:xfrm>
           <a:prstGeom prst="rect">
             <a:avLst/>
@@ -7354,14 +7723,14 @@
       </p:sp>
       <p:sp>
         <p:nvSpPr>
-          <p:cNvPr id="237" name="Текст"/>
+          <p:cNvPr id="249" name="Текст"/>
           <p:cNvSpPr txBox="1"/>
           <p:nvPr/>
         </p:nvSpPr>
         <p:spPr>
           <a:xfrm>
-            <a:off x="12252960" y="8385048"/>
-            <a:ext cx="5303520" cy="822960"/>
+            <a:off x="12252960" y="9025128"/>
+            <a:ext cx="5303520" cy="640080"/>
           </a:xfrm>
           <a:prstGeom prst="rect">
             <a:avLst/>
@@ -7388,13 +7757,13 @@
       </p:sp>
       <p:cxnSp>
         <p:nvCxnSpPr>
-          <p:cNvPr id="238" name="Разделитель"/>
+          <p:cNvPr id="250" name="Разделитель"/>
           <p:cNvCxnSpPr/>
           <p:nvPr/>
         </p:nvCxnSpPr>
         <p:spPr>
           <a:xfrm>
-            <a:off x="1069848" y="9208008"/>
+            <a:off x="1069848" y="9665207"/>
             <a:ext cx="16870679" cy="0"/>
           </a:xfrm>
           <a:prstGeom prst="line">

</xml_diff>

<commit_message>
Brighter demographic indicators slide
Co-Authored-By: Claude Sonnet 5.5 <noreply@anthropic.com>
Claude-Session: https://claude.ai/code/session_01PfagTkBBfn3ShTm5bX9M45
</commit_message>
<xml_diff>
--- a/slide_pokazateli_demografiya.pptx
+++ b/slide_pokazateli_demografiya.pptx
@@ -6302,14 +6302,45 @@
       </p:sp>
       <p:sp>
         <p:nvSpPr>
-          <p:cNvPr id="203" name="Заголовок колонки"/>
+          <p:cNvPr id="203" name="Шапка таблицы"/>
+          <p:cNvSpPr/>
+          <p:nvPr/>
+        </p:nvSpPr>
+        <p:spPr>
+          <a:xfrm>
+            <a:off x="1069848" y="2057400"/>
+            <a:ext cx="16870680" cy="502920"/>
+          </a:xfrm>
+          <a:prstGeom prst="roundRect">
+            <a:avLst>
+              <a:gd name="adj" fmla="val 25000"/>
+            </a:avLst>
+          </a:prstGeom>
+          <a:solidFill>
+            <a:srgbClr val="062D3F"/>
+          </a:solidFill>
+          <a:ln>
+            <a:noFill/>
+          </a:ln>
+        </p:spPr>
+        <p:txBody>
+          <a:bodyPr rtlCol="0" anchor="ctr"/>
+          <a:lstStyle/>
+          <a:p>
+            <a:pPr algn="ctr"/>
+          </a:p>
+        </p:txBody>
+      </p:sp>
+      <p:sp>
+        <p:nvSpPr>
+          <p:cNvPr id="204" name="Заголовок колонки"/>
           <p:cNvSpPr txBox="1"/>
           <p:nvPr/>
         </p:nvSpPr>
         <p:spPr>
           <a:xfrm>
-            <a:off x="1417320" y="2057400"/>
-            <a:ext cx="6766560" cy="365760"/>
+            <a:off x="2148840" y="2057400"/>
+            <a:ext cx="6035040" cy="502920"/>
           </a:xfrm>
           <a:prstGeom prst="rect">
             <a:avLst/>
@@ -6324,26 +6355,163 @@
           <a:p>
             <a:r>
               <a:rPr sz="1600" b="1">
+                <a:solidFill>
+                  <a:srgbClr val="FFFFFF"/>
+                </a:solidFill>
+                <a:latin typeface="Circe Bold"/>
+              </a:rPr>
+              <a:t>ПОКАЗАТЕЛЬ</a:t>
+            </a:r>
+          </a:p>
+        </p:txBody>
+      </p:sp>
+      <p:sp>
+        <p:nvSpPr>
+          <p:cNvPr id="205" name="Заголовок колонки"/>
+          <p:cNvSpPr txBox="1"/>
+          <p:nvPr/>
+        </p:nvSpPr>
+        <p:spPr>
+          <a:xfrm>
+            <a:off x="8412480" y="2057400"/>
+            <a:ext cx="3566160" cy="502920"/>
+          </a:xfrm>
+          <a:prstGeom prst="rect">
+            <a:avLst/>
+          </a:prstGeom>
+          <a:noFill/>
+        </p:spPr>
+        <p:txBody>
+          <a:bodyPr wrap="square" anchor="ctr" lIns="0" rIns="0" tIns="0" bIns="0">
+            <a:spAutoFit/>
+          </a:bodyPr>
+          <a:lstStyle/>
+          <a:p>
+            <a:r>
+              <a:rPr sz="1600" b="1">
+                <a:solidFill>
+                  <a:srgbClr val="FFFFFF"/>
+                </a:solidFill>
+                <a:latin typeface="Circe Bold"/>
+              </a:rPr>
+              <a:t>ЕДИНИЦА</a:t>
+            </a:r>
+          </a:p>
+        </p:txBody>
+      </p:sp>
+      <p:sp>
+        <p:nvSpPr>
+          <p:cNvPr id="206" name="Заголовок колонки"/>
+          <p:cNvSpPr txBox="1"/>
+          <p:nvPr/>
+        </p:nvSpPr>
+        <p:spPr>
+          <a:xfrm>
+            <a:off x="12252960" y="2057400"/>
+            <a:ext cx="5303520" cy="502920"/>
+          </a:xfrm>
+          <a:prstGeom prst="rect">
+            <a:avLst/>
+          </a:prstGeom>
+          <a:noFill/>
+        </p:spPr>
+        <p:txBody>
+          <a:bodyPr wrap="square" anchor="ctr" lIns="0" rIns="0" tIns="0" bIns="0">
+            <a:spAutoFit/>
+          </a:bodyPr>
+          <a:lstStyle/>
+          <a:p>
+            <a:r>
+              <a:rPr sz="1600" b="1">
+                <a:solidFill>
+                  <a:srgbClr val="FFFFFF"/>
+                </a:solidFill>
+                <a:latin typeface="Circe Bold"/>
+              </a:rPr>
+              <a:t>ЧТО ПОКАЗЫВАЕТ</a:t>
+            </a:r>
+          </a:p>
+        </p:txBody>
+      </p:sp>
+      <p:sp>
+        <p:nvSpPr>
+          <p:cNvPr id="207" name="Полоса"/>
+          <p:cNvSpPr/>
+          <p:nvPr/>
+        </p:nvSpPr>
+        <p:spPr>
+          <a:xfrm>
+            <a:off x="1069848" y="2706624"/>
+            <a:ext cx="16870680" cy="566928"/>
+          </a:xfrm>
+          <a:prstGeom prst="roundRect">
+            <a:avLst>
+              <a:gd name="adj" fmla="val 30000"/>
+            </a:avLst>
+          </a:prstGeom>
+          <a:solidFill>
+            <a:srgbClr val="FFF3CC"/>
+          </a:solidFill>
+          <a:ln>
+            <a:noFill/>
+          </a:ln>
+        </p:spPr>
+        <p:txBody>
+          <a:bodyPr rtlCol="0" anchor="ctr"/>
+          <a:lstStyle/>
+          <a:p>
+            <a:pPr algn="ctr"/>
+          </a:p>
+        </p:txBody>
+      </p:sp>
+      <p:sp>
+        <p:nvSpPr>
+          <p:cNvPr id="208" name="Номер 1"/>
+          <p:cNvSpPr/>
+          <p:nvPr/>
+        </p:nvSpPr>
+        <p:spPr>
+          <a:xfrm>
+            <a:off x="1417320" y="2779776"/>
+            <a:ext cx="420624" cy="420624"/>
+          </a:xfrm>
+          <a:prstGeom prst="ellipse">
+            <a:avLst/>
+          </a:prstGeom>
+          <a:solidFill>
+            <a:srgbClr val="FFCC00"/>
+          </a:solidFill>
+          <a:ln>
+            <a:noFill/>
+          </a:ln>
+        </p:spPr>
+        <p:txBody>
+          <a:bodyPr rtlCol="0" anchor="ctr" lIns="0" rIns="0" tIns="0" bIns="0"/>
+          <a:lstStyle/>
+          <a:p>
+            <a:pPr algn="ctr"/>
+            <a:r>
+              <a:rPr sz="1500" b="1">
                 <a:solidFill>
                   <a:srgbClr val="062D3F"/>
                 </a:solidFill>
                 <a:latin typeface="Circe Bold"/>
               </a:rPr>
-              <a:t>ПОКАЗАТЕЛЬ</a:t>
+              <a:t>1</a:t>
             </a:r>
           </a:p>
         </p:txBody>
       </p:sp>
       <p:sp>
         <p:nvSpPr>
-          <p:cNvPr id="204" name="Заголовок колонки"/>
+          <p:cNvPr id="209" name="Текст"/>
           <p:cNvSpPr txBox="1"/>
           <p:nvPr/>
         </p:nvSpPr>
         <p:spPr>
           <a:xfrm>
-            <a:off x="8412480" y="2057400"/>
-            <a:ext cx="3566160" cy="365760"/>
+            <a:off x="2148840" y="2679192"/>
+            <a:ext cx="6035040" cy="621792"/>
           </a:xfrm>
           <a:prstGeom prst="rect">
             <a:avLst/>
@@ -6357,96 +6525,7 @@
           <a:lstStyle/>
           <a:p>
             <a:r>
-              <a:rPr sz="1600" b="1">
-                <a:solidFill>
-                  <a:srgbClr val="062D3F"/>
-                </a:solidFill>
-                <a:latin typeface="Circe Bold"/>
-              </a:rPr>
-              <a:t>ЕДИНИЦА</a:t>
-            </a:r>
-          </a:p>
-        </p:txBody>
-      </p:sp>
-      <p:sp>
-        <p:nvSpPr>
-          <p:cNvPr id="205" name="Заголовок колонки"/>
-          <p:cNvSpPr txBox="1"/>
-          <p:nvPr/>
-        </p:nvSpPr>
-        <p:spPr>
-          <a:xfrm>
-            <a:off x="12252960" y="2057400"/>
-            <a:ext cx="5303520" cy="365760"/>
-          </a:xfrm>
-          <a:prstGeom prst="rect">
-            <a:avLst/>
-          </a:prstGeom>
-          <a:noFill/>
-        </p:spPr>
-        <p:txBody>
-          <a:bodyPr wrap="square" anchor="ctr" lIns="0" rIns="0" tIns="0" bIns="0">
-            <a:spAutoFit/>
-          </a:bodyPr>
-          <a:lstStyle/>
-          <a:p>
-            <a:r>
-              <a:rPr sz="1600" b="1">
-                <a:solidFill>
-                  <a:srgbClr val="062D3F"/>
-                </a:solidFill>
-                <a:latin typeface="Circe Bold"/>
-              </a:rPr>
-              <a:t>ЧТО ПОКАЗЫВАЕТ</a:t>
-            </a:r>
-          </a:p>
-        </p:txBody>
-      </p:sp>
-      <p:cxnSp>
-        <p:nvCxnSpPr>
-          <p:cNvPr id="206" name="Линия заголовка"/>
-          <p:cNvCxnSpPr/>
-          <p:nvPr/>
-        </p:nvCxnSpPr>
-        <p:spPr>
-          <a:xfrm>
-            <a:off x="1069848" y="2514600"/>
-            <a:ext cx="16870679" cy="0"/>
-          </a:xfrm>
-          <a:prstGeom prst="line">
-            <a:avLst/>
-          </a:prstGeom>
-          <a:ln w="19050">
-            <a:solidFill>
-              <a:srgbClr val="062D3F"/>
-            </a:solidFill>
-          </a:ln>
-        </p:spPr>
-      </p:cxnSp>
-      <p:sp>
-        <p:nvSpPr>
-          <p:cNvPr id="207" name="Текст"/>
-          <p:cNvSpPr txBox="1"/>
-          <p:nvPr/>
-        </p:nvSpPr>
-        <p:spPr>
-          <a:xfrm>
-            <a:off x="1417320" y="2624328"/>
-            <a:ext cx="6766560" cy="640080"/>
-          </a:xfrm>
-          <a:prstGeom prst="rect">
-            <a:avLst/>
-          </a:prstGeom>
-          <a:noFill/>
-        </p:spPr>
-        <p:txBody>
-          <a:bodyPr wrap="square" anchor="ctr" lIns="0" rIns="0" tIns="0" bIns="0">
-            <a:spAutoFit/>
-          </a:bodyPr>
-          <a:lstStyle/>
-          <a:p>
-            <a:r>
-              <a:rPr sz="1600" b="1">
+              <a:rPr sz="1700" b="1">
                 <a:solidFill>
                   <a:srgbClr val="062D3F"/>
                 </a:solidFill>
@@ -6459,14 +6538,14 @@
       </p:sp>
       <p:sp>
         <p:nvSpPr>
-          <p:cNvPr id="208" name="Текст"/>
+          <p:cNvPr id="210" name="Текст"/>
           <p:cNvSpPr txBox="1"/>
           <p:nvPr/>
         </p:nvSpPr>
         <p:spPr>
           <a:xfrm>
-            <a:off x="8412480" y="2624328"/>
-            <a:ext cx="3566160" cy="640080"/>
+            <a:off x="8412480" y="2679192"/>
+            <a:ext cx="3566160" cy="621792"/>
           </a:xfrm>
           <a:prstGeom prst="rect">
             <a:avLst/>
@@ -6482,7 +6561,7 @@
             <a:r>
               <a:rPr sz="1600" b="0">
                 <a:solidFill>
-                  <a:srgbClr val="5E6B73"/>
+                  <a:srgbClr val="062D3F"/>
                 </a:solidFill>
                 <a:latin typeface="Circe"/>
               </a:rPr>
@@ -6493,14 +6572,14 @@
       </p:sp>
       <p:sp>
         <p:nvSpPr>
-          <p:cNvPr id="209" name="Текст"/>
+          <p:cNvPr id="211" name="Текст"/>
           <p:cNvSpPr txBox="1"/>
           <p:nvPr/>
         </p:nvSpPr>
         <p:spPr>
           <a:xfrm>
-            <a:off x="12252960" y="2624328"/>
-            <a:ext cx="5303520" cy="640080"/>
+            <a:off x="12252960" y="2679192"/>
+            <a:ext cx="5303520" cy="621792"/>
           </a:xfrm>
           <a:prstGeom prst="rect">
             <a:avLst/>
@@ -6525,37 +6604,54 @@
           </a:p>
         </p:txBody>
       </p:sp>
-      <p:cxnSp>
-        <p:nvCxnSpPr>
-          <p:cNvPr id="210" name="Разделитель"/>
-          <p:cNvCxnSpPr/>
+      <p:sp>
+        <p:nvSpPr>
+          <p:cNvPr id="212" name="Номер 2"/>
+          <p:cNvSpPr/>
           <p:nvPr/>
-        </p:nvCxnSpPr>
-        <p:spPr>
-          <a:xfrm>
-            <a:off x="1069848" y="3264408"/>
-            <a:ext cx="16870679" cy="0"/>
-          </a:xfrm>
-          <a:prstGeom prst="line">
+        </p:nvSpPr>
+        <p:spPr>
+          <a:xfrm>
+            <a:off x="1417320" y="3401568"/>
+            <a:ext cx="420624" cy="420624"/>
+          </a:xfrm>
+          <a:prstGeom prst="ellipse">
             <a:avLst/>
           </a:prstGeom>
-          <a:ln w="12700">
-            <a:solidFill>
-              <a:srgbClr val="D9DEE2"/>
-            </a:solidFill>
+          <a:solidFill>
+            <a:srgbClr val="FFCC00"/>
+          </a:solidFill>
+          <a:ln>
+            <a:noFill/>
           </a:ln>
         </p:spPr>
-      </p:cxnSp>
-      <p:sp>
-        <p:nvSpPr>
-          <p:cNvPr id="211" name="Текст"/>
+        <p:txBody>
+          <a:bodyPr rtlCol="0" anchor="ctr" lIns="0" rIns="0" tIns="0" bIns="0"/>
+          <a:lstStyle/>
+          <a:p>
+            <a:pPr algn="ctr"/>
+            <a:r>
+              <a:rPr sz="1500" b="1">
+                <a:solidFill>
+                  <a:srgbClr val="062D3F"/>
+                </a:solidFill>
+                <a:latin typeface="Circe Bold"/>
+              </a:rPr>
+              <a:t>2</a:t>
+            </a:r>
+          </a:p>
+        </p:txBody>
+      </p:sp>
+      <p:sp>
+        <p:nvSpPr>
+          <p:cNvPr id="213" name="Текст"/>
           <p:cNvSpPr txBox="1"/>
           <p:nvPr/>
         </p:nvSpPr>
         <p:spPr>
           <a:xfrm>
-            <a:off x="1417320" y="3264408"/>
-            <a:ext cx="6766560" cy="640080"/>
+            <a:off x="2148840" y="3300984"/>
+            <a:ext cx="6035040" cy="621792"/>
           </a:xfrm>
           <a:prstGeom prst="rect">
             <a:avLst/>
@@ -6569,7 +6665,7 @@
           <a:lstStyle/>
           <a:p>
             <a:r>
-              <a:rPr sz="1600" b="1">
+              <a:rPr sz="1700" b="1">
                 <a:solidFill>
                   <a:srgbClr val="062D3F"/>
                 </a:solidFill>
@@ -6582,14 +6678,14 @@
       </p:sp>
       <p:sp>
         <p:nvSpPr>
-          <p:cNvPr id="212" name="Текст"/>
+          <p:cNvPr id="214" name="Текст"/>
           <p:cNvSpPr txBox="1"/>
           <p:nvPr/>
         </p:nvSpPr>
         <p:spPr>
           <a:xfrm>
-            <a:off x="8412480" y="3264408"/>
-            <a:ext cx="3566160" cy="640080"/>
+            <a:off x="8412480" y="3300984"/>
+            <a:ext cx="3566160" cy="621792"/>
           </a:xfrm>
           <a:prstGeom prst="rect">
             <a:avLst/>
@@ -6605,7 +6701,7 @@
             <a:r>
               <a:rPr sz="1600" b="0">
                 <a:solidFill>
-                  <a:srgbClr val="5E6B73"/>
+                  <a:srgbClr val="062D3F"/>
                 </a:solidFill>
                 <a:latin typeface="Circe"/>
               </a:rPr>
@@ -6616,14 +6712,14 @@
       </p:sp>
       <p:sp>
         <p:nvSpPr>
-          <p:cNvPr id="213" name="Текст"/>
+          <p:cNvPr id="215" name="Текст"/>
           <p:cNvSpPr txBox="1"/>
           <p:nvPr/>
         </p:nvSpPr>
         <p:spPr>
           <a:xfrm>
-            <a:off x="12252960" y="3264408"/>
-            <a:ext cx="5303520" cy="640080"/>
+            <a:off x="12252960" y="3300984"/>
+            <a:ext cx="5303520" cy="621792"/>
           </a:xfrm>
           <a:prstGeom prst="rect">
             <a:avLst/>
@@ -6648,37 +6744,85 @@
           </a:p>
         </p:txBody>
       </p:sp>
-      <p:cxnSp>
-        <p:nvCxnSpPr>
-          <p:cNvPr id="214" name="Разделитель"/>
-          <p:cNvCxnSpPr/>
+      <p:sp>
+        <p:nvSpPr>
+          <p:cNvPr id="216" name="Полоса"/>
+          <p:cNvSpPr/>
           <p:nvPr/>
-        </p:nvCxnSpPr>
-        <p:spPr>
-          <a:xfrm>
-            <a:off x="1069848" y="3904488"/>
-            <a:ext cx="16870679" cy="0"/>
-          </a:xfrm>
-          <a:prstGeom prst="line">
+        </p:nvSpPr>
+        <p:spPr>
+          <a:xfrm>
+            <a:off x="1069848" y="3950208"/>
+            <a:ext cx="16870680" cy="566928"/>
+          </a:xfrm>
+          <a:prstGeom prst="roundRect">
+            <a:avLst>
+              <a:gd name="adj" fmla="val 30000"/>
+            </a:avLst>
+          </a:prstGeom>
+          <a:solidFill>
+            <a:srgbClr val="FFF3CC"/>
+          </a:solidFill>
+          <a:ln>
+            <a:noFill/>
+          </a:ln>
+        </p:spPr>
+        <p:txBody>
+          <a:bodyPr rtlCol="0" anchor="ctr"/>
+          <a:lstStyle/>
+          <a:p>
+            <a:pPr algn="ctr"/>
+          </a:p>
+        </p:txBody>
+      </p:sp>
+      <p:sp>
+        <p:nvSpPr>
+          <p:cNvPr id="217" name="Номер 3"/>
+          <p:cNvSpPr/>
+          <p:nvPr/>
+        </p:nvSpPr>
+        <p:spPr>
+          <a:xfrm>
+            <a:off x="1417320" y="4023360"/>
+            <a:ext cx="420624" cy="420624"/>
+          </a:xfrm>
+          <a:prstGeom prst="ellipse">
             <a:avLst/>
           </a:prstGeom>
-          <a:ln w="12700">
-            <a:solidFill>
-              <a:srgbClr val="D9DEE2"/>
-            </a:solidFill>
+          <a:solidFill>
+            <a:srgbClr val="FFCC00"/>
+          </a:solidFill>
+          <a:ln>
+            <a:noFill/>
           </a:ln>
         </p:spPr>
-      </p:cxnSp>
-      <p:sp>
-        <p:nvSpPr>
-          <p:cNvPr id="215" name="Текст"/>
+        <p:txBody>
+          <a:bodyPr rtlCol="0" anchor="ctr" lIns="0" rIns="0" tIns="0" bIns="0"/>
+          <a:lstStyle/>
+          <a:p>
+            <a:pPr algn="ctr"/>
+            <a:r>
+              <a:rPr sz="1500" b="1">
+                <a:solidFill>
+                  <a:srgbClr val="062D3F"/>
+                </a:solidFill>
+                <a:latin typeface="Circe Bold"/>
+              </a:rPr>
+              <a:t>3</a:t>
+            </a:r>
+          </a:p>
+        </p:txBody>
+      </p:sp>
+      <p:sp>
+        <p:nvSpPr>
+          <p:cNvPr id="218" name="Текст"/>
           <p:cNvSpPr txBox="1"/>
           <p:nvPr/>
         </p:nvSpPr>
         <p:spPr>
           <a:xfrm>
-            <a:off x="1417320" y="3904488"/>
-            <a:ext cx="6766560" cy="640080"/>
+            <a:off x="2148840" y="3922776"/>
+            <a:ext cx="6035040" cy="621792"/>
           </a:xfrm>
           <a:prstGeom prst="rect">
             <a:avLst/>
@@ -6692,7 +6836,7 @@
           <a:lstStyle/>
           <a:p>
             <a:r>
-              <a:rPr sz="1600" b="1">
+              <a:rPr sz="1700" b="1">
                 <a:solidFill>
                   <a:srgbClr val="062D3F"/>
                 </a:solidFill>
@@ -6705,14 +6849,14 @@
       </p:sp>
       <p:sp>
         <p:nvSpPr>
-          <p:cNvPr id="216" name="Текст"/>
+          <p:cNvPr id="219" name="Текст"/>
           <p:cNvSpPr txBox="1"/>
           <p:nvPr/>
         </p:nvSpPr>
         <p:spPr>
           <a:xfrm>
-            <a:off x="8412480" y="3904488"/>
-            <a:ext cx="3566160" cy="640080"/>
+            <a:off x="8412480" y="3922776"/>
+            <a:ext cx="3566160" cy="621792"/>
           </a:xfrm>
           <a:prstGeom prst="rect">
             <a:avLst/>
@@ -6728,7 +6872,7 @@
             <a:r>
               <a:rPr sz="1600" b="0">
                 <a:solidFill>
-                  <a:srgbClr val="5E6B73"/>
+                  <a:srgbClr val="062D3F"/>
                 </a:solidFill>
                 <a:latin typeface="Circe"/>
               </a:rPr>
@@ -6739,14 +6883,14 @@
       </p:sp>
       <p:sp>
         <p:nvSpPr>
-          <p:cNvPr id="217" name="Текст"/>
+          <p:cNvPr id="220" name="Текст"/>
           <p:cNvSpPr txBox="1"/>
           <p:nvPr/>
         </p:nvSpPr>
         <p:spPr>
           <a:xfrm>
-            <a:off x="12252960" y="3904488"/>
-            <a:ext cx="5303520" cy="640080"/>
+            <a:off x="12252960" y="3922776"/>
+            <a:ext cx="5303520" cy="621792"/>
           </a:xfrm>
           <a:prstGeom prst="rect">
             <a:avLst/>
@@ -6771,37 +6915,54 @@
           </a:p>
         </p:txBody>
       </p:sp>
-      <p:cxnSp>
-        <p:nvCxnSpPr>
-          <p:cNvPr id="218" name="Разделитель"/>
-          <p:cNvCxnSpPr/>
+      <p:sp>
+        <p:nvSpPr>
+          <p:cNvPr id="221" name="Номер 4"/>
+          <p:cNvSpPr/>
           <p:nvPr/>
-        </p:nvCxnSpPr>
-        <p:spPr>
-          <a:xfrm>
-            <a:off x="1069848" y="4544568"/>
-            <a:ext cx="16870679" cy="0"/>
-          </a:xfrm>
-          <a:prstGeom prst="line">
+        </p:nvSpPr>
+        <p:spPr>
+          <a:xfrm>
+            <a:off x="1417320" y="4645152"/>
+            <a:ext cx="420624" cy="420624"/>
+          </a:xfrm>
+          <a:prstGeom prst="ellipse">
             <a:avLst/>
           </a:prstGeom>
-          <a:ln w="12700">
-            <a:solidFill>
-              <a:srgbClr val="D9DEE2"/>
-            </a:solidFill>
+          <a:solidFill>
+            <a:srgbClr val="FFCC00"/>
+          </a:solidFill>
+          <a:ln>
+            <a:noFill/>
           </a:ln>
         </p:spPr>
-      </p:cxnSp>
-      <p:sp>
-        <p:nvSpPr>
-          <p:cNvPr id="219" name="Текст"/>
+        <p:txBody>
+          <a:bodyPr rtlCol="0" anchor="ctr" lIns="0" rIns="0" tIns="0" bIns="0"/>
+          <a:lstStyle/>
+          <a:p>
+            <a:pPr algn="ctr"/>
+            <a:r>
+              <a:rPr sz="1500" b="1">
+                <a:solidFill>
+                  <a:srgbClr val="062D3F"/>
+                </a:solidFill>
+                <a:latin typeface="Circe Bold"/>
+              </a:rPr>
+              <a:t>4</a:t>
+            </a:r>
+          </a:p>
+        </p:txBody>
+      </p:sp>
+      <p:sp>
+        <p:nvSpPr>
+          <p:cNvPr id="222" name="Текст"/>
           <p:cNvSpPr txBox="1"/>
           <p:nvPr/>
         </p:nvSpPr>
         <p:spPr>
           <a:xfrm>
-            <a:off x="1417320" y="4544568"/>
-            <a:ext cx="6766560" cy="640080"/>
+            <a:off x="2148840" y="4544568"/>
+            <a:ext cx="6035040" cy="621792"/>
           </a:xfrm>
           <a:prstGeom prst="rect">
             <a:avLst/>
@@ -6815,7 +6976,7 @@
           <a:lstStyle/>
           <a:p>
             <a:r>
-              <a:rPr sz="1600" b="1">
+              <a:rPr sz="1700" b="1">
                 <a:solidFill>
                   <a:srgbClr val="062D3F"/>
                 </a:solidFill>
@@ -6828,14 +6989,14 @@
       </p:sp>
       <p:sp>
         <p:nvSpPr>
-          <p:cNvPr id="220" name="Текст"/>
+          <p:cNvPr id="223" name="Текст"/>
           <p:cNvSpPr txBox="1"/>
           <p:nvPr/>
         </p:nvSpPr>
         <p:spPr>
           <a:xfrm>
             <a:off x="8412480" y="4544568"/>
-            <a:ext cx="3566160" cy="640080"/>
+            <a:ext cx="3566160" cy="621792"/>
           </a:xfrm>
           <a:prstGeom prst="rect">
             <a:avLst/>
@@ -6851,7 +7012,7 @@
             <a:r>
               <a:rPr sz="1600" b="0">
                 <a:solidFill>
-                  <a:srgbClr val="5E6B73"/>
+                  <a:srgbClr val="062D3F"/>
                 </a:solidFill>
                 <a:latin typeface="Circe"/>
               </a:rPr>
@@ -6862,14 +7023,14 @@
       </p:sp>
       <p:sp>
         <p:nvSpPr>
-          <p:cNvPr id="221" name="Текст"/>
+          <p:cNvPr id="224" name="Текст"/>
           <p:cNvSpPr txBox="1"/>
           <p:nvPr/>
         </p:nvSpPr>
         <p:spPr>
           <a:xfrm>
             <a:off x="12252960" y="4544568"/>
-            <a:ext cx="5303520" cy="640080"/>
+            <a:ext cx="5303520" cy="621792"/>
           </a:xfrm>
           <a:prstGeom prst="rect">
             <a:avLst/>
@@ -6894,37 +7055,85 @@
           </a:p>
         </p:txBody>
       </p:sp>
-      <p:cxnSp>
-        <p:nvCxnSpPr>
-          <p:cNvPr id="222" name="Разделитель"/>
-          <p:cNvCxnSpPr/>
+      <p:sp>
+        <p:nvSpPr>
+          <p:cNvPr id="225" name="Полоса"/>
+          <p:cNvSpPr/>
           <p:nvPr/>
-        </p:nvCxnSpPr>
-        <p:spPr>
-          <a:xfrm>
-            <a:off x="1069848" y="5184648"/>
-            <a:ext cx="16870679" cy="0"/>
-          </a:xfrm>
-          <a:prstGeom prst="line">
+        </p:nvSpPr>
+        <p:spPr>
+          <a:xfrm>
+            <a:off x="1069848" y="5193792"/>
+            <a:ext cx="16870680" cy="566928"/>
+          </a:xfrm>
+          <a:prstGeom prst="roundRect">
+            <a:avLst>
+              <a:gd name="adj" fmla="val 30000"/>
+            </a:avLst>
+          </a:prstGeom>
+          <a:solidFill>
+            <a:srgbClr val="FFF3CC"/>
+          </a:solidFill>
+          <a:ln>
+            <a:noFill/>
+          </a:ln>
+        </p:spPr>
+        <p:txBody>
+          <a:bodyPr rtlCol="0" anchor="ctr"/>
+          <a:lstStyle/>
+          <a:p>
+            <a:pPr algn="ctr"/>
+          </a:p>
+        </p:txBody>
+      </p:sp>
+      <p:sp>
+        <p:nvSpPr>
+          <p:cNvPr id="226" name="Номер 5"/>
+          <p:cNvSpPr/>
+          <p:nvPr/>
+        </p:nvSpPr>
+        <p:spPr>
+          <a:xfrm>
+            <a:off x="1417320" y="5266944"/>
+            <a:ext cx="420624" cy="420624"/>
+          </a:xfrm>
+          <a:prstGeom prst="ellipse">
             <a:avLst/>
           </a:prstGeom>
-          <a:ln w="12700">
-            <a:solidFill>
-              <a:srgbClr val="D9DEE2"/>
-            </a:solidFill>
+          <a:solidFill>
+            <a:srgbClr val="FFCC00"/>
+          </a:solidFill>
+          <a:ln>
+            <a:noFill/>
           </a:ln>
         </p:spPr>
-      </p:cxnSp>
-      <p:sp>
-        <p:nvSpPr>
-          <p:cNvPr id="223" name="Текст"/>
+        <p:txBody>
+          <a:bodyPr rtlCol="0" anchor="ctr" lIns="0" rIns="0" tIns="0" bIns="0"/>
+          <a:lstStyle/>
+          <a:p>
+            <a:pPr algn="ctr"/>
+            <a:r>
+              <a:rPr sz="1500" b="1">
+                <a:solidFill>
+                  <a:srgbClr val="062D3F"/>
+                </a:solidFill>
+                <a:latin typeface="Circe Bold"/>
+              </a:rPr>
+              <a:t>5</a:t>
+            </a:r>
+          </a:p>
+        </p:txBody>
+      </p:sp>
+      <p:sp>
+        <p:nvSpPr>
+          <p:cNvPr id="227" name="Текст"/>
           <p:cNvSpPr txBox="1"/>
           <p:nvPr/>
         </p:nvSpPr>
         <p:spPr>
           <a:xfrm>
-            <a:off x="1417320" y="5184648"/>
-            <a:ext cx="6766560" cy="640080"/>
+            <a:off x="2148840" y="5166359"/>
+            <a:ext cx="6035040" cy="621792"/>
           </a:xfrm>
           <a:prstGeom prst="rect">
             <a:avLst/>
@@ -6938,7 +7147,7 @@
           <a:lstStyle/>
           <a:p>
             <a:r>
-              <a:rPr sz="1600" b="1">
+              <a:rPr sz="1700" b="1">
                 <a:solidFill>
                   <a:srgbClr val="062D3F"/>
                 </a:solidFill>
@@ -6951,14 +7160,14 @@
       </p:sp>
       <p:sp>
         <p:nvSpPr>
-          <p:cNvPr id="224" name="Текст"/>
+          <p:cNvPr id="228" name="Текст"/>
           <p:cNvSpPr txBox="1"/>
           <p:nvPr/>
         </p:nvSpPr>
         <p:spPr>
           <a:xfrm>
-            <a:off x="8412480" y="5184648"/>
-            <a:ext cx="3566160" cy="640080"/>
+            <a:off x="8412480" y="5166359"/>
+            <a:ext cx="3566160" cy="621792"/>
           </a:xfrm>
           <a:prstGeom prst="rect">
             <a:avLst/>
@@ -6974,7 +7183,7 @@
             <a:r>
               <a:rPr sz="1600" b="0">
                 <a:solidFill>
-                  <a:srgbClr val="5E6B73"/>
+                  <a:srgbClr val="062D3F"/>
                 </a:solidFill>
                 <a:latin typeface="Circe"/>
               </a:rPr>
@@ -6985,14 +7194,14 @@
       </p:sp>
       <p:sp>
         <p:nvSpPr>
-          <p:cNvPr id="225" name="Текст"/>
+          <p:cNvPr id="229" name="Текст"/>
           <p:cNvSpPr txBox="1"/>
           <p:nvPr/>
         </p:nvSpPr>
         <p:spPr>
           <a:xfrm>
-            <a:off x="12252960" y="5184648"/>
-            <a:ext cx="5303520" cy="640080"/>
+            <a:off x="12252960" y="5166359"/>
+            <a:ext cx="5303520" cy="621792"/>
           </a:xfrm>
           <a:prstGeom prst="rect">
             <a:avLst/>
@@ -7017,37 +7226,54 @@
           </a:p>
         </p:txBody>
       </p:sp>
-      <p:cxnSp>
-        <p:nvCxnSpPr>
-          <p:cNvPr id="226" name="Разделитель"/>
-          <p:cNvCxnSpPr/>
+      <p:sp>
+        <p:nvSpPr>
+          <p:cNvPr id="230" name="Номер 6"/>
+          <p:cNvSpPr/>
           <p:nvPr/>
-        </p:nvCxnSpPr>
-        <p:spPr>
-          <a:xfrm>
-            <a:off x="1069848" y="5824728"/>
-            <a:ext cx="16870679" cy="0"/>
-          </a:xfrm>
-          <a:prstGeom prst="line">
+        </p:nvSpPr>
+        <p:spPr>
+          <a:xfrm>
+            <a:off x="1417320" y="5888736"/>
+            <a:ext cx="420624" cy="420624"/>
+          </a:xfrm>
+          <a:prstGeom prst="ellipse">
             <a:avLst/>
           </a:prstGeom>
-          <a:ln w="12700">
-            <a:solidFill>
-              <a:srgbClr val="D9DEE2"/>
-            </a:solidFill>
+          <a:solidFill>
+            <a:srgbClr val="FFCC00"/>
+          </a:solidFill>
+          <a:ln>
+            <a:noFill/>
           </a:ln>
         </p:spPr>
-      </p:cxnSp>
-      <p:sp>
-        <p:nvSpPr>
-          <p:cNvPr id="227" name="Текст"/>
+        <p:txBody>
+          <a:bodyPr rtlCol="0" anchor="ctr" lIns="0" rIns="0" tIns="0" bIns="0"/>
+          <a:lstStyle/>
+          <a:p>
+            <a:pPr algn="ctr"/>
+            <a:r>
+              <a:rPr sz="1500" b="1">
+                <a:solidFill>
+                  <a:srgbClr val="062D3F"/>
+                </a:solidFill>
+                <a:latin typeface="Circe Bold"/>
+              </a:rPr>
+              <a:t>6</a:t>
+            </a:r>
+          </a:p>
+        </p:txBody>
+      </p:sp>
+      <p:sp>
+        <p:nvSpPr>
+          <p:cNvPr id="231" name="Текст"/>
           <p:cNvSpPr txBox="1"/>
           <p:nvPr/>
         </p:nvSpPr>
         <p:spPr>
           <a:xfrm>
-            <a:off x="1417320" y="5824728"/>
-            <a:ext cx="6766560" cy="640080"/>
+            <a:off x="2148840" y="5788151"/>
+            <a:ext cx="6035040" cy="621792"/>
           </a:xfrm>
           <a:prstGeom prst="rect">
             <a:avLst/>
@@ -7061,7 +7287,7 @@
           <a:lstStyle/>
           <a:p>
             <a:r>
-              <a:rPr sz="1600" b="1">
+              <a:rPr sz="1700" b="1">
                 <a:solidFill>
                   <a:srgbClr val="062D3F"/>
                 </a:solidFill>
@@ -7074,14 +7300,14 @@
       </p:sp>
       <p:sp>
         <p:nvSpPr>
-          <p:cNvPr id="228" name="Текст"/>
+          <p:cNvPr id="232" name="Текст"/>
           <p:cNvSpPr txBox="1"/>
           <p:nvPr/>
         </p:nvSpPr>
         <p:spPr>
           <a:xfrm>
-            <a:off x="8412480" y="5824728"/>
-            <a:ext cx="3566160" cy="640080"/>
+            <a:off x="8412480" y="5788151"/>
+            <a:ext cx="3566160" cy="621792"/>
           </a:xfrm>
           <a:prstGeom prst="rect">
             <a:avLst/>
@@ -7097,7 +7323,7 @@
             <a:r>
               <a:rPr sz="1600" b="0">
                 <a:solidFill>
-                  <a:srgbClr val="5E6B73"/>
+                  <a:srgbClr val="062D3F"/>
                 </a:solidFill>
                 <a:latin typeface="Circe"/>
               </a:rPr>
@@ -7108,14 +7334,14 @@
       </p:sp>
       <p:sp>
         <p:nvSpPr>
-          <p:cNvPr id="229" name="Текст"/>
+          <p:cNvPr id="233" name="Текст"/>
           <p:cNvSpPr txBox="1"/>
           <p:nvPr/>
         </p:nvSpPr>
         <p:spPr>
           <a:xfrm>
-            <a:off x="12252960" y="5824728"/>
-            <a:ext cx="5303520" cy="640080"/>
+            <a:off x="12252960" y="5788151"/>
+            <a:ext cx="5303520" cy="621792"/>
           </a:xfrm>
           <a:prstGeom prst="rect">
             <a:avLst/>
@@ -7140,37 +7366,85 @@
           </a:p>
         </p:txBody>
       </p:sp>
-      <p:cxnSp>
-        <p:nvCxnSpPr>
-          <p:cNvPr id="230" name="Разделитель"/>
-          <p:cNvCxnSpPr/>
+      <p:sp>
+        <p:nvSpPr>
+          <p:cNvPr id="234" name="Полоса"/>
+          <p:cNvSpPr/>
           <p:nvPr/>
-        </p:nvCxnSpPr>
-        <p:spPr>
-          <a:xfrm>
-            <a:off x="1069848" y="6464808"/>
-            <a:ext cx="16870679" cy="0"/>
-          </a:xfrm>
-          <a:prstGeom prst="line">
+        </p:nvSpPr>
+        <p:spPr>
+          <a:xfrm>
+            <a:off x="1069848" y="6437375"/>
+            <a:ext cx="16870680" cy="566928"/>
+          </a:xfrm>
+          <a:prstGeom prst="roundRect">
+            <a:avLst>
+              <a:gd name="adj" fmla="val 30000"/>
+            </a:avLst>
+          </a:prstGeom>
+          <a:solidFill>
+            <a:srgbClr val="FFF3CC"/>
+          </a:solidFill>
+          <a:ln>
+            <a:noFill/>
+          </a:ln>
+        </p:spPr>
+        <p:txBody>
+          <a:bodyPr rtlCol="0" anchor="ctr"/>
+          <a:lstStyle/>
+          <a:p>
+            <a:pPr algn="ctr"/>
+          </a:p>
+        </p:txBody>
+      </p:sp>
+      <p:sp>
+        <p:nvSpPr>
+          <p:cNvPr id="235" name="Номер 7"/>
+          <p:cNvSpPr/>
+          <p:nvPr/>
+        </p:nvSpPr>
+        <p:spPr>
+          <a:xfrm>
+            <a:off x="1417320" y="6510527"/>
+            <a:ext cx="420624" cy="420624"/>
+          </a:xfrm>
+          <a:prstGeom prst="ellipse">
             <a:avLst/>
           </a:prstGeom>
-          <a:ln w="12700">
-            <a:solidFill>
-              <a:srgbClr val="D9DEE2"/>
-            </a:solidFill>
+          <a:solidFill>
+            <a:srgbClr val="FFCC00"/>
+          </a:solidFill>
+          <a:ln>
+            <a:noFill/>
           </a:ln>
         </p:spPr>
-      </p:cxnSp>
-      <p:sp>
-        <p:nvSpPr>
-          <p:cNvPr id="231" name="Текст"/>
+        <p:txBody>
+          <a:bodyPr rtlCol="0" anchor="ctr" lIns="0" rIns="0" tIns="0" bIns="0"/>
+          <a:lstStyle/>
+          <a:p>
+            <a:pPr algn="ctr"/>
+            <a:r>
+              <a:rPr sz="1500" b="1">
+                <a:solidFill>
+                  <a:srgbClr val="062D3F"/>
+                </a:solidFill>
+                <a:latin typeface="Circe Bold"/>
+              </a:rPr>
+              <a:t>7</a:t>
+            </a:r>
+          </a:p>
+        </p:txBody>
+      </p:sp>
+      <p:sp>
+        <p:nvSpPr>
+          <p:cNvPr id="236" name="Текст"/>
           <p:cNvSpPr txBox="1"/>
           <p:nvPr/>
         </p:nvSpPr>
         <p:spPr>
           <a:xfrm>
-            <a:off x="1417320" y="6464808"/>
-            <a:ext cx="6766560" cy="640080"/>
+            <a:off x="2148840" y="6409943"/>
+            <a:ext cx="6035040" cy="621792"/>
           </a:xfrm>
           <a:prstGeom prst="rect">
             <a:avLst/>
@@ -7184,7 +7458,7 @@
           <a:lstStyle/>
           <a:p>
             <a:r>
-              <a:rPr sz="1600" b="1">
+              <a:rPr sz="1700" b="1">
                 <a:solidFill>
                   <a:srgbClr val="062D3F"/>
                 </a:solidFill>
@@ -7197,14 +7471,14 @@
       </p:sp>
       <p:sp>
         <p:nvSpPr>
-          <p:cNvPr id="232" name="Текст"/>
+          <p:cNvPr id="237" name="Текст"/>
           <p:cNvSpPr txBox="1"/>
           <p:nvPr/>
         </p:nvSpPr>
         <p:spPr>
           <a:xfrm>
-            <a:off x="8412480" y="6464808"/>
-            <a:ext cx="3566160" cy="640080"/>
+            <a:off x="8412480" y="6409943"/>
+            <a:ext cx="3566160" cy="621792"/>
           </a:xfrm>
           <a:prstGeom prst="rect">
             <a:avLst/>
@@ -7220,7 +7494,7 @@
             <a:r>
               <a:rPr sz="1600" b="0">
                 <a:solidFill>
-                  <a:srgbClr val="5E6B73"/>
+                  <a:srgbClr val="062D3F"/>
                 </a:solidFill>
                 <a:latin typeface="Circe"/>
               </a:rPr>
@@ -7231,14 +7505,14 @@
       </p:sp>
       <p:sp>
         <p:nvSpPr>
-          <p:cNvPr id="233" name="Текст"/>
+          <p:cNvPr id="238" name="Текст"/>
           <p:cNvSpPr txBox="1"/>
           <p:nvPr/>
         </p:nvSpPr>
         <p:spPr>
           <a:xfrm>
-            <a:off x="12252960" y="6464808"/>
-            <a:ext cx="5303520" cy="640080"/>
+            <a:off x="12252960" y="6409943"/>
+            <a:ext cx="5303520" cy="621792"/>
           </a:xfrm>
           <a:prstGeom prst="rect">
             <a:avLst/>
@@ -7263,37 +7537,54 @@
           </a:p>
         </p:txBody>
       </p:sp>
-      <p:cxnSp>
-        <p:nvCxnSpPr>
-          <p:cNvPr id="234" name="Разделитель"/>
-          <p:cNvCxnSpPr/>
+      <p:sp>
+        <p:nvSpPr>
+          <p:cNvPr id="239" name="Номер 8"/>
+          <p:cNvSpPr/>
           <p:nvPr/>
-        </p:nvCxnSpPr>
-        <p:spPr>
-          <a:xfrm>
-            <a:off x="1069848" y="7104888"/>
-            <a:ext cx="16870679" cy="0"/>
-          </a:xfrm>
-          <a:prstGeom prst="line">
+        </p:nvSpPr>
+        <p:spPr>
+          <a:xfrm>
+            <a:off x="1417320" y="7132319"/>
+            <a:ext cx="420624" cy="420624"/>
+          </a:xfrm>
+          <a:prstGeom prst="ellipse">
             <a:avLst/>
           </a:prstGeom>
-          <a:ln w="12700">
-            <a:solidFill>
-              <a:srgbClr val="D9DEE2"/>
-            </a:solidFill>
+          <a:solidFill>
+            <a:srgbClr val="FFCC00"/>
+          </a:solidFill>
+          <a:ln>
+            <a:noFill/>
           </a:ln>
         </p:spPr>
-      </p:cxnSp>
-      <p:sp>
-        <p:nvSpPr>
-          <p:cNvPr id="235" name="Текст"/>
+        <p:txBody>
+          <a:bodyPr rtlCol="0" anchor="ctr" lIns="0" rIns="0" tIns="0" bIns="0"/>
+          <a:lstStyle/>
+          <a:p>
+            <a:pPr algn="ctr"/>
+            <a:r>
+              <a:rPr sz="1500" b="1">
+                <a:solidFill>
+                  <a:srgbClr val="062D3F"/>
+                </a:solidFill>
+                <a:latin typeface="Circe Bold"/>
+              </a:rPr>
+              <a:t>8</a:t>
+            </a:r>
+          </a:p>
+        </p:txBody>
+      </p:sp>
+      <p:sp>
+        <p:nvSpPr>
+          <p:cNvPr id="240" name="Текст"/>
           <p:cNvSpPr txBox="1"/>
           <p:nvPr/>
         </p:nvSpPr>
         <p:spPr>
           <a:xfrm>
-            <a:off x="1417320" y="7104888"/>
-            <a:ext cx="6766560" cy="640080"/>
+            <a:off x="2148840" y="7031735"/>
+            <a:ext cx="6035040" cy="621792"/>
           </a:xfrm>
           <a:prstGeom prst="rect">
             <a:avLst/>
@@ -7307,7 +7598,7 @@
           <a:lstStyle/>
           <a:p>
             <a:r>
-              <a:rPr sz="1600" b="1">
+              <a:rPr sz="1700" b="1">
                 <a:solidFill>
                   <a:srgbClr val="062D3F"/>
                 </a:solidFill>
@@ -7320,14 +7611,14 @@
       </p:sp>
       <p:sp>
         <p:nvSpPr>
-          <p:cNvPr id="236" name="Текст"/>
+          <p:cNvPr id="241" name="Текст"/>
           <p:cNvSpPr txBox="1"/>
           <p:nvPr/>
         </p:nvSpPr>
         <p:spPr>
           <a:xfrm>
-            <a:off x="8412480" y="7104888"/>
-            <a:ext cx="3566160" cy="640080"/>
+            <a:off x="8412480" y="7031735"/>
+            <a:ext cx="3566160" cy="621792"/>
           </a:xfrm>
           <a:prstGeom prst="rect">
             <a:avLst/>
@@ -7343,7 +7634,7 @@
             <a:r>
               <a:rPr sz="1600" b="0">
                 <a:solidFill>
-                  <a:srgbClr val="5E6B73"/>
+                  <a:srgbClr val="062D3F"/>
                 </a:solidFill>
                 <a:latin typeface="Circe"/>
               </a:rPr>
@@ -7354,14 +7645,14 @@
       </p:sp>
       <p:sp>
         <p:nvSpPr>
-          <p:cNvPr id="237" name="Текст"/>
+          <p:cNvPr id="242" name="Текст"/>
           <p:cNvSpPr txBox="1"/>
           <p:nvPr/>
         </p:nvSpPr>
         <p:spPr>
           <a:xfrm>
-            <a:off x="12252960" y="7104888"/>
-            <a:ext cx="5303520" cy="640080"/>
+            <a:off x="12252960" y="7031735"/>
+            <a:ext cx="5303520" cy="621792"/>
           </a:xfrm>
           <a:prstGeom prst="rect">
             <a:avLst/>
@@ -7386,37 +7677,85 @@
           </a:p>
         </p:txBody>
       </p:sp>
-      <p:cxnSp>
-        <p:nvCxnSpPr>
-          <p:cNvPr id="238" name="Разделитель"/>
-          <p:cNvCxnSpPr/>
+      <p:sp>
+        <p:nvSpPr>
+          <p:cNvPr id="243" name="Полоса"/>
+          <p:cNvSpPr/>
           <p:nvPr/>
-        </p:nvCxnSpPr>
-        <p:spPr>
-          <a:xfrm>
-            <a:off x="1069848" y="7744968"/>
-            <a:ext cx="16870679" cy="0"/>
-          </a:xfrm>
-          <a:prstGeom prst="line">
+        </p:nvSpPr>
+        <p:spPr>
+          <a:xfrm>
+            <a:off x="1069848" y="7680959"/>
+            <a:ext cx="16870680" cy="566928"/>
+          </a:xfrm>
+          <a:prstGeom prst="roundRect">
+            <a:avLst>
+              <a:gd name="adj" fmla="val 30000"/>
+            </a:avLst>
+          </a:prstGeom>
+          <a:solidFill>
+            <a:srgbClr val="FFF3CC"/>
+          </a:solidFill>
+          <a:ln>
+            <a:noFill/>
+          </a:ln>
+        </p:spPr>
+        <p:txBody>
+          <a:bodyPr rtlCol="0" anchor="ctr"/>
+          <a:lstStyle/>
+          <a:p>
+            <a:pPr algn="ctr"/>
+          </a:p>
+        </p:txBody>
+      </p:sp>
+      <p:sp>
+        <p:nvSpPr>
+          <p:cNvPr id="244" name="Номер 9"/>
+          <p:cNvSpPr/>
+          <p:nvPr/>
+        </p:nvSpPr>
+        <p:spPr>
+          <a:xfrm>
+            <a:off x="1417320" y="7754111"/>
+            <a:ext cx="420624" cy="420624"/>
+          </a:xfrm>
+          <a:prstGeom prst="ellipse">
             <a:avLst/>
           </a:prstGeom>
-          <a:ln w="12700">
-            <a:solidFill>
-              <a:srgbClr val="D9DEE2"/>
-            </a:solidFill>
+          <a:solidFill>
+            <a:srgbClr val="FFCC00"/>
+          </a:solidFill>
+          <a:ln>
+            <a:noFill/>
           </a:ln>
         </p:spPr>
-      </p:cxnSp>
-      <p:sp>
-        <p:nvSpPr>
-          <p:cNvPr id="239" name="Текст"/>
+        <p:txBody>
+          <a:bodyPr rtlCol="0" anchor="ctr" lIns="0" rIns="0" tIns="0" bIns="0"/>
+          <a:lstStyle/>
+          <a:p>
+            <a:pPr algn="ctr"/>
+            <a:r>
+              <a:rPr sz="1500" b="1">
+                <a:solidFill>
+                  <a:srgbClr val="062D3F"/>
+                </a:solidFill>
+                <a:latin typeface="Circe Bold"/>
+              </a:rPr>
+              <a:t>9</a:t>
+            </a:r>
+          </a:p>
+        </p:txBody>
+      </p:sp>
+      <p:sp>
+        <p:nvSpPr>
+          <p:cNvPr id="245" name="Текст"/>
           <p:cNvSpPr txBox="1"/>
           <p:nvPr/>
         </p:nvSpPr>
         <p:spPr>
           <a:xfrm>
-            <a:off x="1417320" y="7744968"/>
-            <a:ext cx="6766560" cy="640080"/>
+            <a:off x="2148840" y="7653527"/>
+            <a:ext cx="6035040" cy="621792"/>
           </a:xfrm>
           <a:prstGeom prst="rect">
             <a:avLst/>
@@ -7430,7 +7769,7 @@
           <a:lstStyle/>
           <a:p>
             <a:r>
-              <a:rPr sz="1600" b="1">
+              <a:rPr sz="1700" b="1">
                 <a:solidFill>
                   <a:srgbClr val="062D3F"/>
                 </a:solidFill>
@@ -7443,14 +7782,14 @@
       </p:sp>
       <p:sp>
         <p:nvSpPr>
-          <p:cNvPr id="240" name="Текст"/>
+          <p:cNvPr id="246" name="Текст"/>
           <p:cNvSpPr txBox="1"/>
           <p:nvPr/>
         </p:nvSpPr>
         <p:spPr>
           <a:xfrm>
-            <a:off x="8412480" y="7744968"/>
-            <a:ext cx="3566160" cy="640080"/>
+            <a:off x="8412480" y="7653527"/>
+            <a:ext cx="3566160" cy="621792"/>
           </a:xfrm>
           <a:prstGeom prst="rect">
             <a:avLst/>
@@ -7466,7 +7805,7 @@
             <a:r>
               <a:rPr sz="1600" b="0">
                 <a:solidFill>
-                  <a:srgbClr val="5E6B73"/>
+                  <a:srgbClr val="062D3F"/>
                 </a:solidFill>
                 <a:latin typeface="Circe"/>
               </a:rPr>
@@ -7477,14 +7816,14 @@
       </p:sp>
       <p:sp>
         <p:nvSpPr>
-          <p:cNvPr id="241" name="Текст"/>
+          <p:cNvPr id="247" name="Текст"/>
           <p:cNvSpPr txBox="1"/>
           <p:nvPr/>
         </p:nvSpPr>
         <p:spPr>
           <a:xfrm>
-            <a:off x="12252960" y="7744968"/>
-            <a:ext cx="5303520" cy="640080"/>
+            <a:off x="12252960" y="7653527"/>
+            <a:ext cx="5303520" cy="621792"/>
           </a:xfrm>
           <a:prstGeom prst="rect">
             <a:avLst/>
@@ -7509,37 +7848,54 @@
           </a:p>
         </p:txBody>
       </p:sp>
-      <p:cxnSp>
-        <p:nvCxnSpPr>
-          <p:cNvPr id="242" name="Разделитель"/>
-          <p:cNvCxnSpPr/>
+      <p:sp>
+        <p:nvSpPr>
+          <p:cNvPr id="248" name="Номер 10"/>
+          <p:cNvSpPr/>
           <p:nvPr/>
-        </p:nvCxnSpPr>
-        <p:spPr>
-          <a:xfrm>
-            <a:off x="1069848" y="8385048"/>
-            <a:ext cx="16870679" cy="0"/>
-          </a:xfrm>
-          <a:prstGeom prst="line">
+        </p:nvSpPr>
+        <p:spPr>
+          <a:xfrm>
+            <a:off x="1417320" y="8375903"/>
+            <a:ext cx="420624" cy="420624"/>
+          </a:xfrm>
+          <a:prstGeom prst="ellipse">
             <a:avLst/>
           </a:prstGeom>
-          <a:ln w="12700">
-            <a:solidFill>
-              <a:srgbClr val="D9DEE2"/>
-            </a:solidFill>
+          <a:solidFill>
+            <a:srgbClr val="FFCC00"/>
+          </a:solidFill>
+          <a:ln>
+            <a:noFill/>
           </a:ln>
         </p:spPr>
-      </p:cxnSp>
-      <p:sp>
-        <p:nvSpPr>
-          <p:cNvPr id="243" name="Текст"/>
+        <p:txBody>
+          <a:bodyPr rtlCol="0" anchor="ctr" lIns="0" rIns="0" tIns="0" bIns="0"/>
+          <a:lstStyle/>
+          <a:p>
+            <a:pPr algn="ctr"/>
+            <a:r>
+              <a:rPr sz="1500" b="1">
+                <a:solidFill>
+                  <a:srgbClr val="062D3F"/>
+                </a:solidFill>
+                <a:latin typeface="Circe Bold"/>
+              </a:rPr>
+              <a:t>10</a:t>
+            </a:r>
+          </a:p>
+        </p:txBody>
+      </p:sp>
+      <p:sp>
+        <p:nvSpPr>
+          <p:cNvPr id="249" name="Текст"/>
           <p:cNvSpPr txBox="1"/>
           <p:nvPr/>
         </p:nvSpPr>
         <p:spPr>
           <a:xfrm>
-            <a:off x="1417320" y="8385048"/>
-            <a:ext cx="6766560" cy="640080"/>
+            <a:off x="2148840" y="8275319"/>
+            <a:ext cx="6035040" cy="621792"/>
           </a:xfrm>
           <a:prstGeom prst="rect">
             <a:avLst/>
@@ -7553,7 +7909,7 @@
           <a:lstStyle/>
           <a:p>
             <a:r>
-              <a:rPr sz="1600" b="1">
+              <a:rPr sz="1700" b="1">
                 <a:solidFill>
                   <a:srgbClr val="062D3F"/>
                 </a:solidFill>
@@ -7566,14 +7922,14 @@
       </p:sp>
       <p:sp>
         <p:nvSpPr>
-          <p:cNvPr id="244" name="Текст"/>
+          <p:cNvPr id="250" name="Текст"/>
           <p:cNvSpPr txBox="1"/>
           <p:nvPr/>
         </p:nvSpPr>
         <p:spPr>
           <a:xfrm>
-            <a:off x="8412480" y="8385048"/>
-            <a:ext cx="3566160" cy="640080"/>
+            <a:off x="8412480" y="8275319"/>
+            <a:ext cx="3566160" cy="621792"/>
           </a:xfrm>
           <a:prstGeom prst="rect">
             <a:avLst/>
@@ -7589,7 +7945,7 @@
             <a:r>
               <a:rPr sz="1600" b="0">
                 <a:solidFill>
-                  <a:srgbClr val="5E6B73"/>
+                  <a:srgbClr val="062D3F"/>
                 </a:solidFill>
                 <a:latin typeface="Circe"/>
               </a:rPr>
@@ -7600,14 +7956,14 @@
       </p:sp>
       <p:sp>
         <p:nvSpPr>
-          <p:cNvPr id="245" name="Текст"/>
+          <p:cNvPr id="251" name="Текст"/>
           <p:cNvSpPr txBox="1"/>
           <p:nvPr/>
         </p:nvSpPr>
         <p:spPr>
           <a:xfrm>
-            <a:off x="12252960" y="8385048"/>
-            <a:ext cx="5303520" cy="640080"/>
+            <a:off x="12252960" y="8275319"/>
+            <a:ext cx="5303520" cy="621792"/>
           </a:xfrm>
           <a:prstGeom prst="rect">
             <a:avLst/>
@@ -7632,37 +7988,85 @@
           </a:p>
         </p:txBody>
       </p:sp>
-      <p:cxnSp>
-        <p:nvCxnSpPr>
-          <p:cNvPr id="246" name="Разделитель"/>
-          <p:cNvCxnSpPr/>
+      <p:sp>
+        <p:nvSpPr>
+          <p:cNvPr id="252" name="Полоса"/>
+          <p:cNvSpPr/>
           <p:nvPr/>
-        </p:nvCxnSpPr>
-        <p:spPr>
-          <a:xfrm>
-            <a:off x="1069848" y="9025128"/>
-            <a:ext cx="16870679" cy="0"/>
-          </a:xfrm>
-          <a:prstGeom prst="line">
+        </p:nvSpPr>
+        <p:spPr>
+          <a:xfrm>
+            <a:off x="1069848" y="8924543"/>
+            <a:ext cx="16870680" cy="566928"/>
+          </a:xfrm>
+          <a:prstGeom prst="roundRect">
+            <a:avLst>
+              <a:gd name="adj" fmla="val 30000"/>
+            </a:avLst>
+          </a:prstGeom>
+          <a:solidFill>
+            <a:srgbClr val="FFF3CC"/>
+          </a:solidFill>
+          <a:ln>
+            <a:noFill/>
+          </a:ln>
+        </p:spPr>
+        <p:txBody>
+          <a:bodyPr rtlCol="0" anchor="ctr"/>
+          <a:lstStyle/>
+          <a:p>
+            <a:pPr algn="ctr"/>
+          </a:p>
+        </p:txBody>
+      </p:sp>
+      <p:sp>
+        <p:nvSpPr>
+          <p:cNvPr id="253" name="Номер 11"/>
+          <p:cNvSpPr/>
+          <p:nvPr/>
+        </p:nvSpPr>
+        <p:spPr>
+          <a:xfrm>
+            <a:off x="1417320" y="8997695"/>
+            <a:ext cx="420624" cy="420624"/>
+          </a:xfrm>
+          <a:prstGeom prst="ellipse">
             <a:avLst/>
           </a:prstGeom>
-          <a:ln w="12700">
-            <a:solidFill>
-              <a:srgbClr val="D9DEE2"/>
-            </a:solidFill>
+          <a:solidFill>
+            <a:srgbClr val="FFCC00"/>
+          </a:solidFill>
+          <a:ln>
+            <a:noFill/>
           </a:ln>
         </p:spPr>
-      </p:cxnSp>
-      <p:sp>
-        <p:nvSpPr>
-          <p:cNvPr id="247" name="Текст"/>
+        <p:txBody>
+          <a:bodyPr rtlCol="0" anchor="ctr" lIns="0" rIns="0" tIns="0" bIns="0"/>
+          <a:lstStyle/>
+          <a:p>
+            <a:pPr algn="ctr"/>
+            <a:r>
+              <a:rPr sz="1500" b="1">
+                <a:solidFill>
+                  <a:srgbClr val="062D3F"/>
+                </a:solidFill>
+                <a:latin typeface="Circe Bold"/>
+              </a:rPr>
+              <a:t>11</a:t>
+            </a:r>
+          </a:p>
+        </p:txBody>
+      </p:sp>
+      <p:sp>
+        <p:nvSpPr>
+          <p:cNvPr id="254" name="Текст"/>
           <p:cNvSpPr txBox="1"/>
           <p:nvPr/>
         </p:nvSpPr>
         <p:spPr>
           <a:xfrm>
-            <a:off x="1417320" y="9025128"/>
-            <a:ext cx="6766560" cy="640080"/>
+            <a:off x="2148840" y="8897111"/>
+            <a:ext cx="6035040" cy="621792"/>
           </a:xfrm>
           <a:prstGeom prst="rect">
             <a:avLst/>
@@ -7676,7 +8080,7 @@
           <a:lstStyle/>
           <a:p>
             <a:r>
-              <a:rPr sz="1600" b="1">
+              <a:rPr sz="1700" b="1">
                 <a:solidFill>
                   <a:srgbClr val="062D3F"/>
                 </a:solidFill>
@@ -7689,14 +8093,14 @@
       </p:sp>
       <p:sp>
         <p:nvSpPr>
-          <p:cNvPr id="248" name="Текст"/>
+          <p:cNvPr id="255" name="Текст"/>
           <p:cNvSpPr txBox="1"/>
           <p:nvPr/>
         </p:nvSpPr>
         <p:spPr>
           <a:xfrm>
-            <a:off x="8412480" y="9025128"/>
-            <a:ext cx="3566160" cy="640080"/>
+            <a:off x="8412480" y="8897111"/>
+            <a:ext cx="3566160" cy="621792"/>
           </a:xfrm>
           <a:prstGeom prst="rect">
             <a:avLst/>
@@ -7712,7 +8116,7 @@
             <a:r>
               <a:rPr sz="1600" b="0">
                 <a:solidFill>
-                  <a:srgbClr val="5E6B73"/>
+                  <a:srgbClr val="062D3F"/>
                 </a:solidFill>
                 <a:latin typeface="Circe"/>
               </a:rPr>
@@ -7723,14 +8127,14 @@
       </p:sp>
       <p:sp>
         <p:nvSpPr>
-          <p:cNvPr id="249" name="Текст"/>
+          <p:cNvPr id="256" name="Текст"/>
           <p:cNvSpPr txBox="1"/>
           <p:nvPr/>
         </p:nvSpPr>
         <p:spPr>
           <a:xfrm>
-            <a:off x="12252960" y="9025128"/>
-            <a:ext cx="5303520" cy="640080"/>
+            <a:off x="12252960" y="8897111"/>
+            <a:ext cx="5303520" cy="621792"/>
           </a:xfrm>
           <a:prstGeom prst="rect">
             <a:avLst/>
@@ -7755,27 +8159,6 @@
           </a:p>
         </p:txBody>
       </p:sp>
-      <p:cxnSp>
-        <p:nvCxnSpPr>
-          <p:cNvPr id="250" name="Разделитель"/>
-          <p:cNvCxnSpPr/>
-          <p:nvPr/>
-        </p:nvCxnSpPr>
-        <p:spPr>
-          <a:xfrm>
-            <a:off x="1069848" y="9665207"/>
-            <a:ext cx="16870679" cy="0"/>
-          </a:xfrm>
-          <a:prstGeom prst="line">
-            <a:avLst/>
-          </a:prstGeom>
-          <a:ln w="12700">
-            <a:solidFill>
-              <a:srgbClr val="D9DEE2"/>
-            </a:solidFill>
-          </a:ln>
-        </p:spPr>
-      </p:cxnSp>
     </p:spTree>
   </p:cSld>
   <p:clrMapOvr>

</xml_diff>

<commit_message>
Add life expectancy and mortality task to demographic indicators slide
Co-Authored-By: Claude Sonnet 5.5 <noreply@anthropic.com>
Claude-Session: https://claude.ai/code/session_01PfagTkBBfn3ShTm5bX9M45
</commit_message>
<xml_diff>
--- a/slide_pokazateli_demografiya.pptx
+++ b/slide_pokazateli_demografiya.pptx
@@ -6442,7 +6442,7 @@
         <p:spPr>
           <a:xfrm>
             <a:off x="1069848" y="2706624"/>
-            <a:ext cx="16870680" cy="566928"/>
+            <a:ext cx="16870680" cy="512064"/>
           </a:xfrm>
           <a:prstGeom prst="roundRect">
             <a:avLst>
@@ -6472,8 +6472,8 @@
         </p:nvSpPr>
         <p:spPr>
           <a:xfrm>
-            <a:off x="1417320" y="2779776"/>
-            <a:ext cx="420624" cy="420624"/>
+            <a:off x="1417320" y="2761488"/>
+            <a:ext cx="402336" cy="402336"/>
           </a:xfrm>
           <a:prstGeom prst="ellipse">
             <a:avLst/>
@@ -6511,7 +6511,7 @@
         <p:spPr>
           <a:xfrm>
             <a:off x="2148840" y="2679192"/>
-            <a:ext cx="6035040" cy="621792"/>
+            <a:ext cx="6035040" cy="566928"/>
           </a:xfrm>
           <a:prstGeom prst="rect">
             <a:avLst/>
@@ -6525,7 +6525,7 @@
           <a:lstStyle/>
           <a:p>
             <a:r>
-              <a:rPr sz="1700" b="1">
+              <a:rPr sz="1650" b="1">
                 <a:solidFill>
                   <a:srgbClr val="062D3F"/>
                 </a:solidFill>
@@ -6545,7 +6545,7 @@
         <p:spPr>
           <a:xfrm>
             <a:off x="8412480" y="2679192"/>
-            <a:ext cx="3566160" cy="621792"/>
+            <a:ext cx="3566160" cy="566928"/>
           </a:xfrm>
           <a:prstGeom prst="rect">
             <a:avLst/>
@@ -6579,7 +6579,7 @@
         <p:spPr>
           <a:xfrm>
             <a:off x="12252960" y="2679192"/>
-            <a:ext cx="5303520" cy="621792"/>
+            <a:ext cx="5303520" cy="566928"/>
           </a:xfrm>
           <a:prstGeom prst="rect">
             <a:avLst/>
@@ -6612,8 +6612,8 @@
         </p:nvSpPr>
         <p:spPr>
           <a:xfrm>
-            <a:off x="1417320" y="3401568"/>
-            <a:ext cx="420624" cy="420624"/>
+            <a:off x="1417320" y="3328416"/>
+            <a:ext cx="402336" cy="402336"/>
           </a:xfrm>
           <a:prstGeom prst="ellipse">
             <a:avLst/>
@@ -6650,8 +6650,8 @@
         </p:nvSpPr>
         <p:spPr>
           <a:xfrm>
-            <a:off x="2148840" y="3300984"/>
-            <a:ext cx="6035040" cy="621792"/>
+            <a:off x="2148840" y="3246120"/>
+            <a:ext cx="6035040" cy="566928"/>
           </a:xfrm>
           <a:prstGeom prst="rect">
             <a:avLst/>
@@ -6665,7 +6665,7 @@
           <a:lstStyle/>
           <a:p>
             <a:r>
-              <a:rPr sz="1700" b="1">
+              <a:rPr sz="1650" b="1">
                 <a:solidFill>
                   <a:srgbClr val="062D3F"/>
                 </a:solidFill>
@@ -6684,8 +6684,8 @@
         </p:nvSpPr>
         <p:spPr>
           <a:xfrm>
-            <a:off x="8412480" y="3300984"/>
-            <a:ext cx="3566160" cy="621792"/>
+            <a:off x="8412480" y="3246120"/>
+            <a:ext cx="3566160" cy="566928"/>
           </a:xfrm>
           <a:prstGeom prst="rect">
             <a:avLst/>
@@ -6718,8 +6718,8 @@
         </p:nvSpPr>
         <p:spPr>
           <a:xfrm>
-            <a:off x="12252960" y="3300984"/>
-            <a:ext cx="5303520" cy="621792"/>
+            <a:off x="12252960" y="3246120"/>
+            <a:ext cx="5303520" cy="566928"/>
           </a:xfrm>
           <a:prstGeom prst="rect">
             <a:avLst/>
@@ -6752,8 +6752,8 @@
         </p:nvSpPr>
         <p:spPr>
           <a:xfrm>
-            <a:off x="1069848" y="3950208"/>
-            <a:ext cx="16870680" cy="566928"/>
+            <a:off x="1069848" y="3840480"/>
+            <a:ext cx="16870680" cy="512064"/>
           </a:xfrm>
           <a:prstGeom prst="roundRect">
             <a:avLst>
@@ -6783,8 +6783,8 @@
         </p:nvSpPr>
         <p:spPr>
           <a:xfrm>
-            <a:off x="1417320" y="4023360"/>
-            <a:ext cx="420624" cy="420624"/>
+            <a:off x="1417320" y="3895344"/>
+            <a:ext cx="402336" cy="402336"/>
           </a:xfrm>
           <a:prstGeom prst="ellipse">
             <a:avLst/>
@@ -6821,8 +6821,8 @@
         </p:nvSpPr>
         <p:spPr>
           <a:xfrm>
-            <a:off x="2148840" y="3922776"/>
-            <a:ext cx="6035040" cy="621792"/>
+            <a:off x="2148840" y="3813048"/>
+            <a:ext cx="6035040" cy="566928"/>
           </a:xfrm>
           <a:prstGeom prst="rect">
             <a:avLst/>
@@ -6836,7 +6836,7 @@
           <a:lstStyle/>
           <a:p>
             <a:r>
-              <a:rPr sz="1700" b="1">
+              <a:rPr sz="1650" b="1">
                 <a:solidFill>
                   <a:srgbClr val="062D3F"/>
                 </a:solidFill>
@@ -6855,8 +6855,8 @@
         </p:nvSpPr>
         <p:spPr>
           <a:xfrm>
-            <a:off x="8412480" y="3922776"/>
-            <a:ext cx="3566160" cy="621792"/>
+            <a:off x="8412480" y="3813048"/>
+            <a:ext cx="3566160" cy="566928"/>
           </a:xfrm>
           <a:prstGeom prst="rect">
             <a:avLst/>
@@ -6889,8 +6889,8 @@
         </p:nvSpPr>
         <p:spPr>
           <a:xfrm>
-            <a:off x="12252960" y="3922776"/>
-            <a:ext cx="5303520" cy="621792"/>
+            <a:off x="12252960" y="3813048"/>
+            <a:ext cx="5303520" cy="566928"/>
           </a:xfrm>
           <a:prstGeom prst="rect">
             <a:avLst/>
@@ -6923,8 +6923,8 @@
         </p:nvSpPr>
         <p:spPr>
           <a:xfrm>
-            <a:off x="1417320" y="4645152"/>
-            <a:ext cx="420624" cy="420624"/>
+            <a:off x="1417320" y="4462272"/>
+            <a:ext cx="402336" cy="402336"/>
           </a:xfrm>
           <a:prstGeom prst="ellipse">
             <a:avLst/>
@@ -6961,8 +6961,8 @@
         </p:nvSpPr>
         <p:spPr>
           <a:xfrm>
-            <a:off x="2148840" y="4544568"/>
-            <a:ext cx="6035040" cy="621792"/>
+            <a:off x="2148840" y="4379976"/>
+            <a:ext cx="6035040" cy="566928"/>
           </a:xfrm>
           <a:prstGeom prst="rect">
             <a:avLst/>
@@ -6976,7 +6976,7 @@
           <a:lstStyle/>
           <a:p>
             <a:r>
-              <a:rPr sz="1700" b="1">
+              <a:rPr sz="1650" b="1">
                 <a:solidFill>
                   <a:srgbClr val="062D3F"/>
                 </a:solidFill>
@@ -6995,8 +6995,8 @@
         </p:nvSpPr>
         <p:spPr>
           <a:xfrm>
-            <a:off x="8412480" y="4544568"/>
-            <a:ext cx="3566160" cy="621792"/>
+            <a:off x="8412480" y="4379976"/>
+            <a:ext cx="3566160" cy="566928"/>
           </a:xfrm>
           <a:prstGeom prst="rect">
             <a:avLst/>
@@ -7029,8 +7029,8 @@
         </p:nvSpPr>
         <p:spPr>
           <a:xfrm>
-            <a:off x="12252960" y="4544568"/>
-            <a:ext cx="5303520" cy="621792"/>
+            <a:off x="12252960" y="4379976"/>
+            <a:ext cx="5303520" cy="566928"/>
           </a:xfrm>
           <a:prstGeom prst="rect">
             <a:avLst/>
@@ -7063,8 +7063,8 @@
         </p:nvSpPr>
         <p:spPr>
           <a:xfrm>
-            <a:off x="1069848" y="5193792"/>
-            <a:ext cx="16870680" cy="566928"/>
+            <a:off x="1069848" y="4974336"/>
+            <a:ext cx="16870680" cy="512064"/>
           </a:xfrm>
           <a:prstGeom prst="roundRect">
             <a:avLst>
@@ -7094,8 +7094,8 @@
         </p:nvSpPr>
         <p:spPr>
           <a:xfrm>
-            <a:off x="1417320" y="5266944"/>
-            <a:ext cx="420624" cy="420624"/>
+            <a:off x="1417320" y="5029200"/>
+            <a:ext cx="402336" cy="402336"/>
           </a:xfrm>
           <a:prstGeom prst="ellipse">
             <a:avLst/>
@@ -7132,8 +7132,8 @@
         </p:nvSpPr>
         <p:spPr>
           <a:xfrm>
-            <a:off x="2148840" y="5166359"/>
-            <a:ext cx="6035040" cy="621792"/>
+            <a:off x="2148840" y="4946904"/>
+            <a:ext cx="6035040" cy="566928"/>
           </a:xfrm>
           <a:prstGeom prst="rect">
             <a:avLst/>
@@ -7147,7 +7147,7 @@
           <a:lstStyle/>
           <a:p>
             <a:r>
-              <a:rPr sz="1700" b="1">
+              <a:rPr sz="1650" b="1">
                 <a:solidFill>
                   <a:srgbClr val="062D3F"/>
                 </a:solidFill>
@@ -7166,8 +7166,8 @@
         </p:nvSpPr>
         <p:spPr>
           <a:xfrm>
-            <a:off x="8412480" y="5166359"/>
-            <a:ext cx="3566160" cy="621792"/>
+            <a:off x="8412480" y="4946904"/>
+            <a:ext cx="3566160" cy="566928"/>
           </a:xfrm>
           <a:prstGeom prst="rect">
             <a:avLst/>
@@ -7200,8 +7200,8 @@
         </p:nvSpPr>
         <p:spPr>
           <a:xfrm>
-            <a:off x="12252960" y="5166359"/>
-            <a:ext cx="5303520" cy="621792"/>
+            <a:off x="12252960" y="4946904"/>
+            <a:ext cx="5303520" cy="566928"/>
           </a:xfrm>
           <a:prstGeom prst="rect">
             <a:avLst/>
@@ -7234,8 +7234,8 @@
         </p:nvSpPr>
         <p:spPr>
           <a:xfrm>
-            <a:off x="1417320" y="5888736"/>
-            <a:ext cx="420624" cy="420624"/>
+            <a:off x="1417320" y="5596128"/>
+            <a:ext cx="402336" cy="402336"/>
           </a:xfrm>
           <a:prstGeom prst="ellipse">
             <a:avLst/>
@@ -7272,8 +7272,8 @@
         </p:nvSpPr>
         <p:spPr>
           <a:xfrm>
-            <a:off x="2148840" y="5788151"/>
-            <a:ext cx="6035040" cy="621792"/>
+            <a:off x="2148840" y="5513832"/>
+            <a:ext cx="6035040" cy="566928"/>
           </a:xfrm>
           <a:prstGeom prst="rect">
             <a:avLst/>
@@ -7287,7 +7287,7 @@
           <a:lstStyle/>
           <a:p>
             <a:r>
-              <a:rPr sz="1700" b="1">
+              <a:rPr sz="1650" b="1">
                 <a:solidFill>
                   <a:srgbClr val="062D3F"/>
                 </a:solidFill>
@@ -7306,8 +7306,8 @@
         </p:nvSpPr>
         <p:spPr>
           <a:xfrm>
-            <a:off x="8412480" y="5788151"/>
-            <a:ext cx="3566160" cy="621792"/>
+            <a:off x="8412480" y="5513832"/>
+            <a:ext cx="3566160" cy="566928"/>
           </a:xfrm>
           <a:prstGeom prst="rect">
             <a:avLst/>
@@ -7340,8 +7340,8 @@
         </p:nvSpPr>
         <p:spPr>
           <a:xfrm>
-            <a:off x="12252960" y="5788151"/>
-            <a:ext cx="5303520" cy="621792"/>
+            <a:off x="12252960" y="5513832"/>
+            <a:ext cx="5303520" cy="566928"/>
           </a:xfrm>
           <a:prstGeom prst="rect">
             <a:avLst/>
@@ -7361,7 +7361,7 @@
                 </a:solidFill>
                 <a:latin typeface="Circe"/>
               </a:rPr>
-              <a:t>Факт и целевые показатели стратегии</a:t>
+              <a:t>Факт, целевые показатели стратегии и задача по сокращению смертности</a:t>
             </a:r>
           </a:p>
         </p:txBody>
@@ -7374,8 +7374,8 @@
         </p:nvSpPr>
         <p:spPr>
           <a:xfrm>
-            <a:off x="1069848" y="6437375"/>
-            <a:ext cx="16870680" cy="566928"/>
+            <a:off x="1069848" y="6108192"/>
+            <a:ext cx="16870680" cy="512064"/>
           </a:xfrm>
           <a:prstGeom prst="roundRect">
             <a:avLst>
@@ -7405,8 +7405,8 @@
         </p:nvSpPr>
         <p:spPr>
           <a:xfrm>
-            <a:off x="1417320" y="6510527"/>
-            <a:ext cx="420624" cy="420624"/>
+            <a:off x="1417320" y="6163056"/>
+            <a:ext cx="402336" cy="402336"/>
           </a:xfrm>
           <a:prstGeom prst="ellipse">
             <a:avLst/>
@@ -7443,8 +7443,8 @@
         </p:nvSpPr>
         <p:spPr>
           <a:xfrm>
-            <a:off x="2148840" y="6409943"/>
-            <a:ext cx="6035040" cy="621792"/>
+            <a:off x="2148840" y="6080760"/>
+            <a:ext cx="6035040" cy="566928"/>
           </a:xfrm>
           <a:prstGeom prst="rect">
             <a:avLst/>
@@ -7458,13 +7458,13 @@
           <a:lstStyle/>
           <a:p>
             <a:r>
-              <a:rPr sz="1700" b="1">
+              <a:rPr sz="1650" b="1">
                 <a:solidFill>
                   <a:srgbClr val="062D3F"/>
                 </a:solidFill>
                 <a:latin typeface="Circe Bold"/>
               </a:rPr>
-              <a:t>Коэффициент естественного прироста</a:t>
+              <a:t>Ожидаемая продолжительность жизни</a:t>
             </a:r>
           </a:p>
         </p:txBody>
@@ -7477,8 +7477,8 @@
         </p:nvSpPr>
         <p:spPr>
           <a:xfrm>
-            <a:off x="8412480" y="6409943"/>
-            <a:ext cx="3566160" cy="621792"/>
+            <a:off x="8412480" y="6080760"/>
+            <a:ext cx="3566160" cy="566928"/>
           </a:xfrm>
           <a:prstGeom prst="rect">
             <a:avLst/>
@@ -7498,7 +7498,7 @@
                 </a:solidFill>
                 <a:latin typeface="Circe"/>
               </a:rPr>
-              <a:t>на 1000 населения</a:t>
+              <a:t>лет, мужчины и женщины</a:t>
             </a:r>
           </a:p>
         </p:txBody>
@@ -7511,8 +7511,8 @@
         </p:nvSpPr>
         <p:spPr>
           <a:xfrm>
-            <a:off x="12252960" y="6409943"/>
-            <a:ext cx="5303520" cy="621792"/>
+            <a:off x="12252960" y="6080760"/>
+            <a:ext cx="5303520" cy="566928"/>
           </a:xfrm>
           <a:prstGeom prst="rect">
             <a:avLst/>
@@ -7532,7 +7532,7 @@
                 </a:solidFill>
                 <a:latin typeface="Circe"/>
               </a:rPr>
-              <a:t>Факт и целевые показатели стратегии</a:t>
+              <a:t>Целевой показатель прогноза</a:t>
             </a:r>
           </a:p>
         </p:txBody>
@@ -7545,8 +7545,8 @@
         </p:nvSpPr>
         <p:spPr>
           <a:xfrm>
-            <a:off x="1417320" y="7132319"/>
-            <a:ext cx="420624" cy="420624"/>
+            <a:off x="1417320" y="6729984"/>
+            <a:ext cx="402336" cy="402336"/>
           </a:xfrm>
           <a:prstGeom prst="ellipse">
             <a:avLst/>
@@ -7583,8 +7583,8 @@
         </p:nvSpPr>
         <p:spPr>
           <a:xfrm>
-            <a:off x="2148840" y="7031735"/>
-            <a:ext cx="6035040" cy="621792"/>
+            <a:off x="2148840" y="6647688"/>
+            <a:ext cx="6035040" cy="566928"/>
           </a:xfrm>
           <a:prstGeom prst="rect">
             <a:avLst/>
@@ -7598,13 +7598,13 @@
           <a:lstStyle/>
           <a:p>
             <a:r>
-              <a:rPr sz="1700" b="1">
+              <a:rPr sz="1650" b="1">
                 <a:solidFill>
                   <a:srgbClr val="062D3F"/>
                 </a:solidFill>
                 <a:latin typeface="Circe Bold"/>
               </a:rPr>
-              <a:t>Коэффициент миграционного прироста</a:t>
+              <a:t>Коэффициент естественного прироста</a:t>
             </a:r>
           </a:p>
         </p:txBody>
@@ -7617,8 +7617,8 @@
         </p:nvSpPr>
         <p:spPr>
           <a:xfrm>
-            <a:off x="8412480" y="7031735"/>
-            <a:ext cx="3566160" cy="621792"/>
+            <a:off x="8412480" y="6647688"/>
+            <a:ext cx="3566160" cy="566928"/>
           </a:xfrm>
           <a:prstGeom prst="rect">
             <a:avLst/>
@@ -7651,8 +7651,8 @@
         </p:nvSpPr>
         <p:spPr>
           <a:xfrm>
-            <a:off x="12252960" y="7031735"/>
-            <a:ext cx="5303520" cy="621792"/>
+            <a:off x="12252960" y="6647688"/>
+            <a:ext cx="5303520" cy="566928"/>
           </a:xfrm>
           <a:prstGeom prst="rect">
             <a:avLst/>
@@ -7685,8 +7685,8 @@
         </p:nvSpPr>
         <p:spPr>
           <a:xfrm>
-            <a:off x="1069848" y="7680959"/>
-            <a:ext cx="16870680" cy="566928"/>
+            <a:off x="1069848" y="7242048"/>
+            <a:ext cx="16870680" cy="512064"/>
           </a:xfrm>
           <a:prstGeom prst="roundRect">
             <a:avLst>
@@ -7716,8 +7716,8 @@
         </p:nvSpPr>
         <p:spPr>
           <a:xfrm>
-            <a:off x="1417320" y="7754111"/>
-            <a:ext cx="420624" cy="420624"/>
+            <a:off x="1417320" y="7296912"/>
+            <a:ext cx="402336" cy="402336"/>
           </a:xfrm>
           <a:prstGeom prst="ellipse">
             <a:avLst/>
@@ -7754,8 +7754,8 @@
         </p:nvSpPr>
         <p:spPr>
           <a:xfrm>
-            <a:off x="2148840" y="7653527"/>
-            <a:ext cx="6035040" cy="621792"/>
+            <a:off x="2148840" y="7214616"/>
+            <a:ext cx="6035040" cy="566928"/>
           </a:xfrm>
           <a:prstGeom prst="rect">
             <a:avLst/>
@@ -7769,13 +7769,13 @@
           <a:lstStyle/>
           <a:p>
             <a:r>
-              <a:rPr sz="1700" b="1">
+              <a:rPr sz="1650" b="1">
                 <a:solidFill>
                   <a:srgbClr val="062D3F"/>
                 </a:solidFill>
                 <a:latin typeface="Circe Bold"/>
               </a:rPr>
-              <a:t>Численность населения по полу и однолетним возрастам</a:t>
+              <a:t>Коэффициент миграционного прироста</a:t>
             </a:r>
           </a:p>
         </p:txBody>
@@ -7788,8 +7788,8 @@
         </p:nvSpPr>
         <p:spPr>
           <a:xfrm>
-            <a:off x="8412480" y="7653527"/>
-            <a:ext cx="3566160" cy="621792"/>
+            <a:off x="8412480" y="7214616"/>
+            <a:ext cx="3566160" cy="566928"/>
           </a:xfrm>
           <a:prstGeom prst="rect">
             <a:avLst/>
@@ -7809,7 +7809,7 @@
                 </a:solidFill>
                 <a:latin typeface="Circe"/>
               </a:rPr>
-              <a:t>чел.</a:t>
+              <a:t>на 1000 населения</a:t>
             </a:r>
           </a:p>
         </p:txBody>
@@ -7822,8 +7822,8 @@
         </p:nvSpPr>
         <p:spPr>
           <a:xfrm>
-            <a:off x="12252960" y="7653527"/>
-            <a:ext cx="5303520" cy="621792"/>
+            <a:off x="12252960" y="7214616"/>
+            <a:ext cx="5303520" cy="566928"/>
           </a:xfrm>
           <a:prstGeom prst="rect">
             <a:avLst/>
@@ -7843,7 +7843,7 @@
                 </a:solidFill>
                 <a:latin typeface="Circe"/>
               </a:rPr>
-              <a:t>Половозрастная структура на выбранные годы</a:t>
+              <a:t>Факт и целевые показатели стратегии</a:t>
             </a:r>
           </a:p>
         </p:txBody>
@@ -7856,8 +7856,8 @@
         </p:nvSpPr>
         <p:spPr>
           <a:xfrm>
-            <a:off x="1417320" y="8375903"/>
-            <a:ext cx="420624" cy="420624"/>
+            <a:off x="1417320" y="7863840"/>
+            <a:ext cx="402336" cy="402336"/>
           </a:xfrm>
           <a:prstGeom prst="ellipse">
             <a:avLst/>
@@ -7894,8 +7894,8 @@
         </p:nvSpPr>
         <p:spPr>
           <a:xfrm>
-            <a:off x="2148840" y="8275319"/>
-            <a:ext cx="6035040" cy="621792"/>
+            <a:off x="2148840" y="7781544"/>
+            <a:ext cx="6035040" cy="566928"/>
           </a:xfrm>
           <a:prstGeom prst="rect">
             <a:avLst/>
@@ -7909,13 +7909,13 @@
           <a:lstStyle/>
           <a:p>
             <a:r>
-              <a:rPr sz="1700" b="1">
+              <a:rPr sz="1650" b="1">
                 <a:solidFill>
                   <a:srgbClr val="062D3F"/>
                 </a:solidFill>
                 <a:latin typeface="Circe Bold"/>
               </a:rPr>
-              <a:t>Средний возраст населения</a:t>
+              <a:t>Численность населения по полу и однолетним возрастам</a:t>
             </a:r>
           </a:p>
         </p:txBody>
@@ -7928,8 +7928,8 @@
         </p:nvSpPr>
         <p:spPr>
           <a:xfrm>
-            <a:off x="8412480" y="8275319"/>
-            <a:ext cx="3566160" cy="621792"/>
+            <a:off x="8412480" y="7781544"/>
+            <a:ext cx="3566160" cy="566928"/>
           </a:xfrm>
           <a:prstGeom prst="rect">
             <a:avLst/>
@@ -7949,7 +7949,7 @@
                 </a:solidFill>
                 <a:latin typeface="Circe"/>
               </a:rPr>
-              <a:t>лет, всего, мужчины, женщины</a:t>
+              <a:t>чел.</a:t>
             </a:r>
           </a:p>
         </p:txBody>
@@ -7962,8 +7962,8 @@
         </p:nvSpPr>
         <p:spPr>
           <a:xfrm>
-            <a:off x="12252960" y="8275319"/>
-            <a:ext cx="5303520" cy="621792"/>
+            <a:off x="12252960" y="7781544"/>
+            <a:ext cx="5303520" cy="566928"/>
           </a:xfrm>
           <a:prstGeom prst="rect">
             <a:avLst/>
@@ -7983,7 +7983,7 @@
                 </a:solidFill>
                 <a:latin typeface="Circe"/>
               </a:rPr>
-              <a:t>Старение населения по годам</a:t>
+              <a:t>Половозрастная структура на выбранные годы</a:t>
             </a:r>
           </a:p>
         </p:txBody>
@@ -7996,8 +7996,8 @@
         </p:nvSpPr>
         <p:spPr>
           <a:xfrm>
-            <a:off x="1069848" y="8924543"/>
-            <a:ext cx="16870680" cy="566928"/>
+            <a:off x="1069848" y="8375903"/>
+            <a:ext cx="16870680" cy="512064"/>
           </a:xfrm>
           <a:prstGeom prst="roundRect">
             <a:avLst>
@@ -8027,8 +8027,8 @@
         </p:nvSpPr>
         <p:spPr>
           <a:xfrm>
-            <a:off x="1417320" y="8997695"/>
-            <a:ext cx="420624" cy="420624"/>
+            <a:off x="1417320" y="8430767"/>
+            <a:ext cx="402336" cy="402336"/>
           </a:xfrm>
           <a:prstGeom prst="ellipse">
             <a:avLst/>
@@ -8065,8 +8065,8 @@
         </p:nvSpPr>
         <p:spPr>
           <a:xfrm>
-            <a:off x="2148840" y="8897111"/>
-            <a:ext cx="6035040" cy="621792"/>
+            <a:off x="2148840" y="8348471"/>
+            <a:ext cx="6035040" cy="566928"/>
           </a:xfrm>
           <a:prstGeom prst="rect">
             <a:avLst/>
@@ -8080,7 +8080,147 @@
           <a:lstStyle/>
           <a:p>
             <a:r>
-              <a:rPr sz="1700" b="1">
+              <a:rPr sz="1650" b="1">
+                <a:solidFill>
+                  <a:srgbClr val="062D3F"/>
+                </a:solidFill>
+                <a:latin typeface="Circe Bold"/>
+              </a:rPr>
+              <a:t>Средний возраст населения</a:t>
+            </a:r>
+          </a:p>
+        </p:txBody>
+      </p:sp>
+      <p:sp>
+        <p:nvSpPr>
+          <p:cNvPr id="255" name="Текст"/>
+          <p:cNvSpPr txBox="1"/>
+          <p:nvPr/>
+        </p:nvSpPr>
+        <p:spPr>
+          <a:xfrm>
+            <a:off x="8412480" y="8348471"/>
+            <a:ext cx="3566160" cy="566928"/>
+          </a:xfrm>
+          <a:prstGeom prst="rect">
+            <a:avLst/>
+          </a:prstGeom>
+          <a:noFill/>
+        </p:spPr>
+        <p:txBody>
+          <a:bodyPr wrap="square" anchor="ctr" lIns="0" rIns="0" tIns="0" bIns="0">
+            <a:spAutoFit/>
+          </a:bodyPr>
+          <a:lstStyle/>
+          <a:p>
+            <a:r>
+              <a:rPr sz="1600" b="0">
+                <a:solidFill>
+                  <a:srgbClr val="062D3F"/>
+                </a:solidFill>
+                <a:latin typeface="Circe"/>
+              </a:rPr>
+              <a:t>лет, всего, мужчины, женщины</a:t>
+            </a:r>
+          </a:p>
+        </p:txBody>
+      </p:sp>
+      <p:sp>
+        <p:nvSpPr>
+          <p:cNvPr id="256" name="Текст"/>
+          <p:cNvSpPr txBox="1"/>
+          <p:nvPr/>
+        </p:nvSpPr>
+        <p:spPr>
+          <a:xfrm>
+            <a:off x="12252960" y="8348471"/>
+            <a:ext cx="5303520" cy="566928"/>
+          </a:xfrm>
+          <a:prstGeom prst="rect">
+            <a:avLst/>
+          </a:prstGeom>
+          <a:noFill/>
+        </p:spPr>
+        <p:txBody>
+          <a:bodyPr wrap="square" anchor="ctr" lIns="0" rIns="0" tIns="0" bIns="0">
+            <a:spAutoFit/>
+          </a:bodyPr>
+          <a:lstStyle/>
+          <a:p>
+            <a:r>
+              <a:rPr sz="1600" b="0">
+                <a:solidFill>
+                  <a:srgbClr val="062D3F"/>
+                </a:solidFill>
+                <a:latin typeface="Circe"/>
+              </a:rPr>
+              <a:t>Старение населения по годам</a:t>
+            </a:r>
+          </a:p>
+        </p:txBody>
+      </p:sp>
+      <p:sp>
+        <p:nvSpPr>
+          <p:cNvPr id="257" name="Номер 12"/>
+          <p:cNvSpPr/>
+          <p:nvPr/>
+        </p:nvSpPr>
+        <p:spPr>
+          <a:xfrm>
+            <a:off x="1417320" y="8997695"/>
+            <a:ext cx="402336" cy="402336"/>
+          </a:xfrm>
+          <a:prstGeom prst="ellipse">
+            <a:avLst/>
+          </a:prstGeom>
+          <a:solidFill>
+            <a:srgbClr val="FFCC00"/>
+          </a:solidFill>
+          <a:ln>
+            <a:noFill/>
+          </a:ln>
+        </p:spPr>
+        <p:txBody>
+          <a:bodyPr rtlCol="0" anchor="ctr" lIns="0" rIns="0" tIns="0" bIns="0"/>
+          <a:lstStyle/>
+          <a:p>
+            <a:pPr algn="ctr"/>
+            <a:r>
+              <a:rPr sz="1500" b="1">
+                <a:solidFill>
+                  <a:srgbClr val="062D3F"/>
+                </a:solidFill>
+                <a:latin typeface="Circe Bold"/>
+              </a:rPr>
+              <a:t>12</a:t>
+            </a:r>
+          </a:p>
+        </p:txBody>
+      </p:sp>
+      <p:sp>
+        <p:nvSpPr>
+          <p:cNvPr id="258" name="Текст"/>
+          <p:cNvSpPr txBox="1"/>
+          <p:nvPr/>
+        </p:nvSpPr>
+        <p:spPr>
+          <a:xfrm>
+            <a:off x="2148840" y="8915399"/>
+            <a:ext cx="6035040" cy="566928"/>
+          </a:xfrm>
+          <a:prstGeom prst="rect">
+            <a:avLst/>
+          </a:prstGeom>
+          <a:noFill/>
+        </p:spPr>
+        <p:txBody>
+          <a:bodyPr wrap="square" anchor="ctr" lIns="0" rIns="0" tIns="0" bIns="0">
+            <a:spAutoFit/>
+          </a:bodyPr>
+          <a:lstStyle/>
+          <a:p>
+            <a:r>
+              <a:rPr sz="1650" b="1">
                 <a:solidFill>
                   <a:srgbClr val="062D3F"/>
                 </a:solidFill>
@@ -8093,14 +8233,14 @@
       </p:sp>
       <p:sp>
         <p:nvSpPr>
-          <p:cNvPr id="255" name="Текст"/>
+          <p:cNvPr id="259" name="Текст"/>
           <p:cNvSpPr txBox="1"/>
           <p:nvPr/>
         </p:nvSpPr>
         <p:spPr>
           <a:xfrm>
-            <a:off x="8412480" y="8897111"/>
-            <a:ext cx="3566160" cy="621792"/>
+            <a:off x="8412480" y="8915399"/>
+            <a:ext cx="3566160" cy="566928"/>
           </a:xfrm>
           <a:prstGeom prst="rect">
             <a:avLst/>
@@ -8127,14 +8267,14 @@
       </p:sp>
       <p:sp>
         <p:nvSpPr>
-          <p:cNvPr id="256" name="Текст"/>
+          <p:cNvPr id="260" name="Текст"/>
           <p:cNvSpPr txBox="1"/>
           <p:nvPr/>
         </p:nvSpPr>
         <p:spPr>
           <a:xfrm>
-            <a:off x="12252960" y="8897111"/>
-            <a:ext cx="5303520" cy="621792"/>
+            <a:off x="12252960" y="8915399"/>
+            <a:ext cx="5303520" cy="566928"/>
           </a:xfrm>
           <a:prstGeom prst="rect">
             <a:avLst/>

</xml_diff>

<commit_message>
Add data sources column to demographic indicators slide
Co-Authored-By: Claude Sonnet 5.5 <noreply@anthropic.com>
Claude-Session: https://claude.ai/code/session_01PfagTkBBfn3ShTm5bX9M45
</commit_message>
<xml_diff>
--- a/slide_pokazateli_demografiya.pptx
+++ b/slide_pokazateli_demografiya.pptx
@@ -430,7 +430,7 @@
           <a:lstStyle/>
           <a:p>
             <a:r>
-              <a:t>Единый перечень составлен по содержимому слайдов 22 и 23 презентации (демографический прогноз Великого Новгорода с суммарным коэффициентом рождаемости и половозрастная структура), без привязки к конкретным слайдам. Источники данных в презентации для этих примеров указаны на самих слайдах (Новгородстат, Башкортостанстат), поэтому отдельной колонки нет.</a:t>
+              <a:t>Единый перечень составлен по содержимому слайдов 22 и 23 презентации. Колонка источников написана по общим сведениям о публикации данных (БД ПМО, ЕМИСС, региональные органы Росстата, итоги ВПН-2020), названия таблиц и доступность данных по муниципалитетам нужно сверить. Ожидаемая продолжительность жизни и суммарный коэффициент рождаемости официально публикуются по региону, на уровне района их берут региональными или считают.</a:t>
             </a:r>
           </a:p>
         </p:txBody>
@@ -6339,8 +6339,8 @@
         </p:nvSpPr>
         <p:spPr>
           <a:xfrm>
-            <a:off x="2148840" y="2057400"/>
-            <a:ext cx="6035040" cy="502920"/>
+            <a:off x="2011680" y="2057400"/>
+            <a:ext cx="5029200" cy="502920"/>
           </a:xfrm>
           <a:prstGeom prst="rect">
             <a:avLst/>
@@ -6373,8 +6373,8 @@
         </p:nvSpPr>
         <p:spPr>
           <a:xfrm>
-            <a:off x="8412480" y="2057400"/>
-            <a:ext cx="3566160" cy="502920"/>
+            <a:off x="7178040" y="2057400"/>
+            <a:ext cx="2743200" cy="502920"/>
           </a:xfrm>
           <a:prstGeom prst="rect">
             <a:avLst/>
@@ -6407,8 +6407,8 @@
         </p:nvSpPr>
         <p:spPr>
           <a:xfrm>
-            <a:off x="12252960" y="2057400"/>
-            <a:ext cx="5303520" cy="502920"/>
+            <a:off x="10058400" y="2057400"/>
+            <a:ext cx="3657600" cy="502920"/>
           </a:xfrm>
           <a:prstGeom prst="rect">
             <a:avLst/>
@@ -6435,7 +6435,41 @@
       </p:sp>
       <p:sp>
         <p:nvSpPr>
-          <p:cNvPr id="207" name="Полоса"/>
+          <p:cNvPr id="207" name="Заголовок колонки"/>
+          <p:cNvSpPr txBox="1"/>
+          <p:nvPr/>
+        </p:nvSpPr>
+        <p:spPr>
+          <a:xfrm>
+            <a:off x="13853160" y="2057400"/>
+            <a:ext cx="4023360" cy="502920"/>
+          </a:xfrm>
+          <a:prstGeom prst="rect">
+            <a:avLst/>
+          </a:prstGeom>
+          <a:noFill/>
+        </p:spPr>
+        <p:txBody>
+          <a:bodyPr wrap="square" anchor="ctr" lIns="0" rIns="0" tIns="0" bIns="0">
+            <a:spAutoFit/>
+          </a:bodyPr>
+          <a:lstStyle/>
+          <a:p>
+            <a:r>
+              <a:rPr sz="1600" b="1">
+                <a:solidFill>
+                  <a:srgbClr val="FFFFFF"/>
+                </a:solidFill>
+                <a:latin typeface="Circe Bold"/>
+              </a:rPr>
+              <a:t>ИСТОЧНИК ДАННЫХ</a:t>
+            </a:r>
+          </a:p>
+        </p:txBody>
+      </p:sp>
+      <p:sp>
+        <p:nvSpPr>
+          <p:cNvPr id="208" name="Полоса"/>
           <p:cNvSpPr/>
           <p:nvPr/>
         </p:nvSpPr>
@@ -6466,7 +6500,7 @@
       </p:sp>
       <p:sp>
         <p:nvSpPr>
-          <p:cNvPr id="208" name="Номер 1"/>
+          <p:cNvPr id="209" name="Номер 1"/>
           <p:cNvSpPr/>
           <p:nvPr/>
         </p:nvSpPr>
@@ -6504,14 +6538,14 @@
       </p:sp>
       <p:sp>
         <p:nvSpPr>
-          <p:cNvPr id="209" name="Текст"/>
+          <p:cNvPr id="210" name="Текст"/>
           <p:cNvSpPr txBox="1"/>
           <p:nvPr/>
         </p:nvSpPr>
         <p:spPr>
           <a:xfrm>
-            <a:off x="2148840" y="2679192"/>
-            <a:ext cx="6035040" cy="566928"/>
+            <a:off x="2011680" y="2679192"/>
+            <a:ext cx="5029200" cy="566928"/>
           </a:xfrm>
           <a:prstGeom prst="rect">
             <a:avLst/>
@@ -6525,7 +6559,7 @@
           <a:lstStyle/>
           <a:p>
             <a:r>
-              <a:rPr sz="1650" b="1">
+              <a:rPr sz="1500" b="1">
                 <a:solidFill>
                   <a:srgbClr val="062D3F"/>
                 </a:solidFill>
@@ -6538,14 +6572,14 @@
       </p:sp>
       <p:sp>
         <p:nvSpPr>
-          <p:cNvPr id="210" name="Текст"/>
+          <p:cNvPr id="211" name="Текст"/>
           <p:cNvSpPr txBox="1"/>
           <p:nvPr/>
         </p:nvSpPr>
         <p:spPr>
           <a:xfrm>
-            <a:off x="8412480" y="2679192"/>
-            <a:ext cx="3566160" cy="566928"/>
+            <a:off x="7178040" y="2679192"/>
+            <a:ext cx="2743200" cy="566928"/>
           </a:xfrm>
           <a:prstGeom prst="rect">
             <a:avLst/>
@@ -6559,7 +6593,7 @@
           <a:lstStyle/>
           <a:p>
             <a:r>
-              <a:rPr sz="1600" b="0">
+              <a:rPr sz="1400" b="0">
                 <a:solidFill>
                   <a:srgbClr val="062D3F"/>
                 </a:solidFill>
@@ -6572,14 +6606,14 @@
       </p:sp>
       <p:sp>
         <p:nvSpPr>
-          <p:cNvPr id="211" name="Текст"/>
+          <p:cNvPr id="212" name="Текст"/>
           <p:cNvSpPr txBox="1"/>
           <p:nvPr/>
         </p:nvSpPr>
         <p:spPr>
           <a:xfrm>
-            <a:off x="12252960" y="2679192"/>
-            <a:ext cx="5303520" cy="566928"/>
+            <a:off x="10058400" y="2679192"/>
+            <a:ext cx="3657600" cy="566928"/>
           </a:xfrm>
           <a:prstGeom prst="rect">
             <a:avLst/>
@@ -6593,7 +6627,7 @@
           <a:lstStyle/>
           <a:p>
             <a:r>
-              <a:rPr sz="1600" b="0">
+              <a:rPr sz="1400" b="0">
                 <a:solidFill>
                   <a:srgbClr val="062D3F"/>
                 </a:solidFill>
@@ -6606,7 +6640,41 @@
       </p:sp>
       <p:sp>
         <p:nvSpPr>
-          <p:cNvPr id="212" name="Номер 2"/>
+          <p:cNvPr id="213" name="Текст"/>
+          <p:cNvSpPr txBox="1"/>
+          <p:nvPr/>
+        </p:nvSpPr>
+        <p:spPr>
+          <a:xfrm>
+            <a:off x="13853160" y="2679192"/>
+            <a:ext cx="4023360" cy="566928"/>
+          </a:xfrm>
+          <a:prstGeom prst="rect">
+            <a:avLst/>
+          </a:prstGeom>
+          <a:noFill/>
+        </p:spPr>
+        <p:txBody>
+          <a:bodyPr wrap="square" anchor="ctr" lIns="0" rIns="0" tIns="0" bIns="0">
+            <a:spAutoFit/>
+          </a:bodyPr>
+          <a:lstStyle/>
+          <a:p>
+            <a:r>
+              <a:rPr sz="1400" b="0">
+                <a:solidFill>
+                  <a:srgbClr val="062D3F"/>
+                </a:solidFill>
+                <a:latin typeface="Circe"/>
+              </a:rPr>
+              <a:t>БД ПМО, ЕМИСС, прогноз Росстата и расчёт по сценариям</a:t>
+            </a:r>
+          </a:p>
+        </p:txBody>
+      </p:sp>
+      <p:sp>
+        <p:nvSpPr>
+          <p:cNvPr id="214" name="Номер 2"/>
           <p:cNvSpPr/>
           <p:nvPr/>
         </p:nvSpPr>
@@ -6644,14 +6712,14 @@
       </p:sp>
       <p:sp>
         <p:nvSpPr>
-          <p:cNvPr id="213" name="Текст"/>
+          <p:cNvPr id="215" name="Текст"/>
           <p:cNvSpPr txBox="1"/>
           <p:nvPr/>
         </p:nvSpPr>
         <p:spPr>
           <a:xfrm>
-            <a:off x="2148840" y="3246120"/>
-            <a:ext cx="6035040" cy="566928"/>
+            <a:off x="2011680" y="3246120"/>
+            <a:ext cx="5029200" cy="566928"/>
           </a:xfrm>
           <a:prstGeom prst="rect">
             <a:avLst/>
@@ -6665,7 +6733,7 @@
           <a:lstStyle/>
           <a:p>
             <a:r>
-              <a:rPr sz="1650" b="1">
+              <a:rPr sz="1500" b="1">
                 <a:solidFill>
                   <a:srgbClr val="062D3F"/>
                 </a:solidFill>
@@ -6678,14 +6746,14 @@
       </p:sp>
       <p:sp>
         <p:nvSpPr>
-          <p:cNvPr id="214" name="Текст"/>
+          <p:cNvPr id="216" name="Текст"/>
           <p:cNvSpPr txBox="1"/>
           <p:nvPr/>
         </p:nvSpPr>
         <p:spPr>
           <a:xfrm>
-            <a:off x="8412480" y="3246120"/>
-            <a:ext cx="3566160" cy="566928"/>
+            <a:off x="7178040" y="3246120"/>
+            <a:ext cx="2743200" cy="566928"/>
           </a:xfrm>
           <a:prstGeom prst="rect">
             <a:avLst/>
@@ -6699,7 +6767,7 @@
           <a:lstStyle/>
           <a:p>
             <a:r>
-              <a:rPr sz="1600" b="0">
+              <a:rPr sz="1400" b="0">
                 <a:solidFill>
                   <a:srgbClr val="062D3F"/>
                 </a:solidFill>
@@ -6712,14 +6780,14 @@
       </p:sp>
       <p:sp>
         <p:nvSpPr>
-          <p:cNvPr id="215" name="Текст"/>
+          <p:cNvPr id="217" name="Текст"/>
           <p:cNvSpPr txBox="1"/>
           <p:nvPr/>
         </p:nvSpPr>
         <p:spPr>
           <a:xfrm>
-            <a:off x="12252960" y="3246120"/>
-            <a:ext cx="5303520" cy="566928"/>
+            <a:off x="10058400" y="3246120"/>
+            <a:ext cx="3657600" cy="566928"/>
           </a:xfrm>
           <a:prstGeom prst="rect">
             <a:avLst/>
@@ -6733,7 +6801,7 @@
           <a:lstStyle/>
           <a:p>
             <a:r>
-              <a:rPr sz="1600" b="0">
+              <a:rPr sz="1400" b="0">
                 <a:solidFill>
                   <a:srgbClr val="062D3F"/>
                 </a:solidFill>
@@ -6746,7 +6814,41 @@
       </p:sp>
       <p:sp>
         <p:nvSpPr>
-          <p:cNvPr id="216" name="Полоса"/>
+          <p:cNvPr id="218" name="Текст"/>
+          <p:cNvSpPr txBox="1"/>
+          <p:nvPr/>
+        </p:nvSpPr>
+        <p:spPr>
+          <a:xfrm>
+            <a:off x="13853160" y="3246120"/>
+            <a:ext cx="4023360" cy="566928"/>
+          </a:xfrm>
+          <a:prstGeom prst="rect">
+            <a:avLst/>
+          </a:prstGeom>
+          <a:noFill/>
+        </p:spPr>
+        <p:txBody>
+          <a:bodyPr wrap="square" anchor="ctr" lIns="0" rIns="0" tIns="0" bIns="0">
+            <a:spAutoFit/>
+          </a:bodyPr>
+          <a:lstStyle/>
+          <a:p>
+            <a:r>
+              <a:rPr sz="1400" b="0">
+                <a:solidFill>
+                  <a:srgbClr val="062D3F"/>
+                </a:solidFill>
+                <a:latin typeface="Circe"/>
+              </a:rPr>
+              <a:t>БД ПМО, стратегия СЭР</a:t>
+            </a:r>
+          </a:p>
+        </p:txBody>
+      </p:sp>
+      <p:sp>
+        <p:nvSpPr>
+          <p:cNvPr id="219" name="Полоса"/>
           <p:cNvSpPr/>
           <p:nvPr/>
         </p:nvSpPr>
@@ -6777,7 +6879,7 @@
       </p:sp>
       <p:sp>
         <p:nvSpPr>
-          <p:cNvPr id="217" name="Номер 3"/>
+          <p:cNvPr id="220" name="Номер 3"/>
           <p:cNvSpPr/>
           <p:nvPr/>
         </p:nvSpPr>
@@ -6815,14 +6917,14 @@
       </p:sp>
       <p:sp>
         <p:nvSpPr>
-          <p:cNvPr id="218" name="Текст"/>
+          <p:cNvPr id="221" name="Текст"/>
           <p:cNvSpPr txBox="1"/>
           <p:nvPr/>
         </p:nvSpPr>
         <p:spPr>
           <a:xfrm>
-            <a:off x="2148840" y="3813048"/>
-            <a:ext cx="6035040" cy="566928"/>
+            <a:off x="2011680" y="3813048"/>
+            <a:ext cx="5029200" cy="566928"/>
           </a:xfrm>
           <a:prstGeom prst="rect">
             <a:avLst/>
@@ -6836,7 +6938,7 @@
           <a:lstStyle/>
           <a:p>
             <a:r>
-              <a:rPr sz="1650" b="1">
+              <a:rPr sz="1500" b="1">
                 <a:solidFill>
                   <a:srgbClr val="062D3F"/>
                 </a:solidFill>
@@ -6849,14 +6951,14 @@
       </p:sp>
       <p:sp>
         <p:nvSpPr>
-          <p:cNvPr id="219" name="Текст"/>
+          <p:cNvPr id="222" name="Текст"/>
           <p:cNvSpPr txBox="1"/>
           <p:nvPr/>
         </p:nvSpPr>
         <p:spPr>
           <a:xfrm>
-            <a:off x="8412480" y="3813048"/>
-            <a:ext cx="3566160" cy="566928"/>
+            <a:off x="7178040" y="3813048"/>
+            <a:ext cx="2743200" cy="566928"/>
           </a:xfrm>
           <a:prstGeom prst="rect">
             <a:avLst/>
@@ -6870,7 +6972,7 @@
           <a:lstStyle/>
           <a:p>
             <a:r>
-              <a:rPr sz="1600" b="0">
+              <a:rPr sz="1400" b="0">
                 <a:solidFill>
                   <a:srgbClr val="062D3F"/>
                 </a:solidFill>
@@ -6883,14 +6985,14 @@
       </p:sp>
       <p:sp>
         <p:nvSpPr>
-          <p:cNvPr id="220" name="Текст"/>
+          <p:cNvPr id="223" name="Текст"/>
           <p:cNvSpPr txBox="1"/>
           <p:nvPr/>
         </p:nvSpPr>
         <p:spPr>
           <a:xfrm>
-            <a:off x="12252960" y="3813048"/>
-            <a:ext cx="5303520" cy="566928"/>
+            <a:off x="10058400" y="3813048"/>
+            <a:ext cx="3657600" cy="566928"/>
           </a:xfrm>
           <a:prstGeom prst="rect">
             <a:avLst/>
@@ -6904,7 +7006,7 @@
           <a:lstStyle/>
           <a:p>
             <a:r>
-              <a:rPr sz="1600" b="0">
+              <a:rPr sz="1400" b="0">
                 <a:solidFill>
                   <a:srgbClr val="062D3F"/>
                 </a:solidFill>
@@ -6917,7 +7019,41 @@
       </p:sp>
       <p:sp>
         <p:nvSpPr>
-          <p:cNvPr id="221" name="Номер 4"/>
+          <p:cNvPr id="224" name="Текст"/>
+          <p:cNvSpPr txBox="1"/>
+          <p:nvPr/>
+        </p:nvSpPr>
+        <p:spPr>
+          <a:xfrm>
+            <a:off x="13853160" y="3813048"/>
+            <a:ext cx="4023360" cy="566928"/>
+          </a:xfrm>
+          <a:prstGeom prst="rect">
+            <a:avLst/>
+          </a:prstGeom>
+          <a:noFill/>
+        </p:spPr>
+        <p:txBody>
+          <a:bodyPr wrap="square" anchor="ctr" lIns="0" rIns="0" tIns="0" bIns="0">
+            <a:spAutoFit/>
+          </a:bodyPr>
+          <a:lstStyle/>
+          <a:p>
+            <a:r>
+              <a:rPr sz="1400" b="0">
+                <a:solidFill>
+                  <a:srgbClr val="062D3F"/>
+                </a:solidFill>
+                <a:latin typeface="Circe"/>
+              </a:rPr>
+              <a:t>Расчёт по рождениям и женщинам 15–49 лет, Росстат по региону</a:t>
+            </a:r>
+          </a:p>
+        </p:txBody>
+      </p:sp>
+      <p:sp>
+        <p:nvSpPr>
+          <p:cNvPr id="225" name="Номер 4"/>
           <p:cNvSpPr/>
           <p:nvPr/>
         </p:nvSpPr>
@@ -6955,14 +7091,14 @@
       </p:sp>
       <p:sp>
         <p:nvSpPr>
-          <p:cNvPr id="222" name="Текст"/>
+          <p:cNvPr id="226" name="Текст"/>
           <p:cNvSpPr txBox="1"/>
           <p:nvPr/>
         </p:nvSpPr>
         <p:spPr>
           <a:xfrm>
-            <a:off x="2148840" y="4379976"/>
-            <a:ext cx="6035040" cy="566928"/>
+            <a:off x="2011680" y="4379976"/>
+            <a:ext cx="5029200" cy="566928"/>
           </a:xfrm>
           <a:prstGeom prst="rect">
             <a:avLst/>
@@ -6976,7 +7112,7 @@
           <a:lstStyle/>
           <a:p>
             <a:r>
-              <a:rPr sz="1650" b="1">
+              <a:rPr sz="1500" b="1">
                 <a:solidFill>
                   <a:srgbClr val="062D3F"/>
                 </a:solidFill>
@@ -6989,14 +7125,14 @@
       </p:sp>
       <p:sp>
         <p:nvSpPr>
-          <p:cNvPr id="223" name="Текст"/>
+          <p:cNvPr id="227" name="Текст"/>
           <p:cNvSpPr txBox="1"/>
           <p:nvPr/>
         </p:nvSpPr>
         <p:spPr>
           <a:xfrm>
-            <a:off x="8412480" y="4379976"/>
-            <a:ext cx="3566160" cy="566928"/>
+            <a:off x="7178040" y="4379976"/>
+            <a:ext cx="2743200" cy="566928"/>
           </a:xfrm>
           <a:prstGeom prst="rect">
             <a:avLst/>
@@ -7010,7 +7146,7 @@
           <a:lstStyle/>
           <a:p>
             <a:r>
-              <a:rPr sz="1600" b="0">
+              <a:rPr sz="1400" b="0">
                 <a:solidFill>
                   <a:srgbClr val="062D3F"/>
                 </a:solidFill>
@@ -7023,14 +7159,14 @@
       </p:sp>
       <p:sp>
         <p:nvSpPr>
-          <p:cNvPr id="224" name="Текст"/>
+          <p:cNvPr id="228" name="Текст"/>
           <p:cNvSpPr txBox="1"/>
           <p:nvPr/>
         </p:nvSpPr>
         <p:spPr>
           <a:xfrm>
-            <a:off x="12252960" y="4379976"/>
-            <a:ext cx="5303520" cy="566928"/>
+            <a:off x="10058400" y="4379976"/>
+            <a:ext cx="3657600" cy="566928"/>
           </a:xfrm>
           <a:prstGeom prst="rect">
             <a:avLst/>
@@ -7044,7 +7180,7 @@
           <a:lstStyle/>
           <a:p>
             <a:r>
-              <a:rPr sz="1600" b="0">
+              <a:rPr sz="1400" b="0">
                 <a:solidFill>
                   <a:srgbClr val="062D3F"/>
                 </a:solidFill>
@@ -7057,7 +7193,41 @@
       </p:sp>
       <p:sp>
         <p:nvSpPr>
-          <p:cNvPr id="225" name="Полоса"/>
+          <p:cNvPr id="229" name="Текст"/>
+          <p:cNvSpPr txBox="1"/>
+          <p:nvPr/>
+        </p:nvSpPr>
+        <p:spPr>
+          <a:xfrm>
+            <a:off x="13853160" y="4379976"/>
+            <a:ext cx="4023360" cy="566928"/>
+          </a:xfrm>
+          <a:prstGeom prst="rect">
+            <a:avLst/>
+          </a:prstGeom>
+          <a:noFill/>
+        </p:spPr>
+        <p:txBody>
+          <a:bodyPr wrap="square" anchor="ctr" lIns="0" rIns="0" tIns="0" bIns="0">
+            <a:spAutoFit/>
+          </a:bodyPr>
+          <a:lstStyle/>
+          <a:p>
+            <a:r>
+              <a:rPr sz="1400" b="0">
+                <a:solidFill>
+                  <a:srgbClr val="062D3F"/>
+                </a:solidFill>
+                <a:latin typeface="Circe"/>
+              </a:rPr>
+              <a:t>БД ПМО, региональный Росстат</a:t>
+            </a:r>
+          </a:p>
+        </p:txBody>
+      </p:sp>
+      <p:sp>
+        <p:nvSpPr>
+          <p:cNvPr id="230" name="Полоса"/>
           <p:cNvSpPr/>
           <p:nvPr/>
         </p:nvSpPr>
@@ -7088,7 +7258,7 @@
       </p:sp>
       <p:sp>
         <p:nvSpPr>
-          <p:cNvPr id="226" name="Номер 5"/>
+          <p:cNvPr id="231" name="Номер 5"/>
           <p:cNvSpPr/>
           <p:nvPr/>
         </p:nvSpPr>
@@ -7126,14 +7296,14 @@
       </p:sp>
       <p:sp>
         <p:nvSpPr>
-          <p:cNvPr id="227" name="Текст"/>
+          <p:cNvPr id="232" name="Текст"/>
           <p:cNvSpPr txBox="1"/>
           <p:nvPr/>
         </p:nvSpPr>
         <p:spPr>
           <a:xfrm>
-            <a:off x="2148840" y="4946904"/>
-            <a:ext cx="6035040" cy="566928"/>
+            <a:off x="2011680" y="4946904"/>
+            <a:ext cx="5029200" cy="566928"/>
           </a:xfrm>
           <a:prstGeom prst="rect">
             <a:avLst/>
@@ -7147,7 +7317,7 @@
           <a:lstStyle/>
           <a:p>
             <a:r>
-              <a:rPr sz="1650" b="1">
+              <a:rPr sz="1500" b="1">
                 <a:solidFill>
                   <a:srgbClr val="062D3F"/>
                 </a:solidFill>
@@ -7160,14 +7330,14 @@
       </p:sp>
       <p:sp>
         <p:nvSpPr>
-          <p:cNvPr id="228" name="Текст"/>
+          <p:cNvPr id="233" name="Текст"/>
           <p:cNvSpPr txBox="1"/>
           <p:nvPr/>
         </p:nvSpPr>
         <p:spPr>
           <a:xfrm>
-            <a:off x="8412480" y="4946904"/>
-            <a:ext cx="3566160" cy="566928"/>
+            <a:off x="7178040" y="4946904"/>
+            <a:ext cx="2743200" cy="566928"/>
           </a:xfrm>
           <a:prstGeom prst="rect">
             <a:avLst/>
@@ -7181,7 +7351,7 @@
           <a:lstStyle/>
           <a:p>
             <a:r>
-              <a:rPr sz="1600" b="0">
+              <a:rPr sz="1400" b="0">
                 <a:solidFill>
                   <a:srgbClr val="062D3F"/>
                 </a:solidFill>
@@ -7194,14 +7364,14 @@
       </p:sp>
       <p:sp>
         <p:nvSpPr>
-          <p:cNvPr id="229" name="Текст"/>
+          <p:cNvPr id="234" name="Текст"/>
           <p:cNvSpPr txBox="1"/>
           <p:nvPr/>
         </p:nvSpPr>
         <p:spPr>
           <a:xfrm>
-            <a:off x="12252960" y="4946904"/>
-            <a:ext cx="5303520" cy="566928"/>
+            <a:off x="10058400" y="4946904"/>
+            <a:ext cx="3657600" cy="566928"/>
           </a:xfrm>
           <a:prstGeom prst="rect">
             <a:avLst/>
@@ -7215,7 +7385,7 @@
           <a:lstStyle/>
           <a:p>
             <a:r>
-              <a:rPr sz="1600" b="0">
+              <a:rPr sz="1400" b="0">
                 <a:solidFill>
                   <a:srgbClr val="062D3F"/>
                 </a:solidFill>
@@ -7228,7 +7398,41 @@
       </p:sp>
       <p:sp>
         <p:nvSpPr>
-          <p:cNvPr id="230" name="Номер 6"/>
+          <p:cNvPr id="235" name="Текст"/>
+          <p:cNvSpPr txBox="1"/>
+          <p:nvPr/>
+        </p:nvSpPr>
+        <p:spPr>
+          <a:xfrm>
+            <a:off x="13853160" y="4946904"/>
+            <a:ext cx="4023360" cy="566928"/>
+          </a:xfrm>
+          <a:prstGeom prst="rect">
+            <a:avLst/>
+          </a:prstGeom>
+          <a:noFill/>
+        </p:spPr>
+        <p:txBody>
+          <a:bodyPr wrap="square" anchor="ctr" lIns="0" rIns="0" tIns="0" bIns="0">
+            <a:spAutoFit/>
+          </a:bodyPr>
+          <a:lstStyle/>
+          <a:p>
+            <a:r>
+              <a:rPr sz="1400" b="0">
+                <a:solidFill>
+                  <a:srgbClr val="062D3F"/>
+                </a:solidFill>
+                <a:latin typeface="Circe"/>
+              </a:rPr>
+              <a:t>БД ПМО, стратегия СЭР</a:t>
+            </a:r>
+          </a:p>
+        </p:txBody>
+      </p:sp>
+      <p:sp>
+        <p:nvSpPr>
+          <p:cNvPr id="236" name="Номер 6"/>
           <p:cNvSpPr/>
           <p:nvPr/>
         </p:nvSpPr>
@@ -7266,14 +7470,14 @@
       </p:sp>
       <p:sp>
         <p:nvSpPr>
-          <p:cNvPr id="231" name="Текст"/>
+          <p:cNvPr id="237" name="Текст"/>
           <p:cNvSpPr txBox="1"/>
           <p:nvPr/>
         </p:nvSpPr>
         <p:spPr>
           <a:xfrm>
-            <a:off x="2148840" y="5513832"/>
-            <a:ext cx="6035040" cy="566928"/>
+            <a:off x="2011680" y="5513832"/>
+            <a:ext cx="5029200" cy="566928"/>
           </a:xfrm>
           <a:prstGeom prst="rect">
             <a:avLst/>
@@ -7287,7 +7491,7 @@
           <a:lstStyle/>
           <a:p>
             <a:r>
-              <a:rPr sz="1650" b="1">
+              <a:rPr sz="1500" b="1">
                 <a:solidFill>
                   <a:srgbClr val="062D3F"/>
                 </a:solidFill>
@@ -7300,14 +7504,14 @@
       </p:sp>
       <p:sp>
         <p:nvSpPr>
-          <p:cNvPr id="232" name="Текст"/>
+          <p:cNvPr id="238" name="Текст"/>
           <p:cNvSpPr txBox="1"/>
           <p:nvPr/>
         </p:nvSpPr>
         <p:spPr>
           <a:xfrm>
-            <a:off x="8412480" y="5513832"/>
-            <a:ext cx="3566160" cy="566928"/>
+            <a:off x="7178040" y="5513832"/>
+            <a:ext cx="2743200" cy="566928"/>
           </a:xfrm>
           <a:prstGeom prst="rect">
             <a:avLst/>
@@ -7321,7 +7525,7 @@
           <a:lstStyle/>
           <a:p>
             <a:r>
-              <a:rPr sz="1600" b="0">
+              <a:rPr sz="1400" b="0">
                 <a:solidFill>
                   <a:srgbClr val="062D3F"/>
                 </a:solidFill>
@@ -7334,14 +7538,14 @@
       </p:sp>
       <p:sp>
         <p:nvSpPr>
-          <p:cNvPr id="233" name="Текст"/>
+          <p:cNvPr id="239" name="Текст"/>
           <p:cNvSpPr txBox="1"/>
           <p:nvPr/>
         </p:nvSpPr>
         <p:spPr>
           <a:xfrm>
-            <a:off x="12252960" y="5513832"/>
-            <a:ext cx="5303520" cy="566928"/>
+            <a:off x="10058400" y="5513832"/>
+            <a:ext cx="3657600" cy="566928"/>
           </a:xfrm>
           <a:prstGeom prst="rect">
             <a:avLst/>
@@ -7355,7 +7559,7 @@
           <a:lstStyle/>
           <a:p>
             <a:r>
-              <a:rPr sz="1600" b="0">
+              <a:rPr sz="1400" b="0">
                 <a:solidFill>
                   <a:srgbClr val="062D3F"/>
                 </a:solidFill>
@@ -7368,7 +7572,41 @@
       </p:sp>
       <p:sp>
         <p:nvSpPr>
-          <p:cNvPr id="234" name="Полоса"/>
+          <p:cNvPr id="240" name="Текст"/>
+          <p:cNvSpPr txBox="1"/>
+          <p:nvPr/>
+        </p:nvSpPr>
+        <p:spPr>
+          <a:xfrm>
+            <a:off x="13853160" y="5513832"/>
+            <a:ext cx="4023360" cy="566928"/>
+          </a:xfrm>
+          <a:prstGeom prst="rect">
+            <a:avLst/>
+          </a:prstGeom>
+          <a:noFill/>
+        </p:spPr>
+        <p:txBody>
+          <a:bodyPr wrap="square" anchor="ctr" lIns="0" rIns="0" tIns="0" bIns="0">
+            <a:spAutoFit/>
+          </a:bodyPr>
+          <a:lstStyle/>
+          <a:p>
+            <a:r>
+              <a:rPr sz="1400" b="0">
+                <a:solidFill>
+                  <a:srgbClr val="062D3F"/>
+                </a:solidFill>
+                <a:latin typeface="Circe"/>
+              </a:rPr>
+              <a:t>БД ПМО, стратегия СЭР</a:t>
+            </a:r>
+          </a:p>
+        </p:txBody>
+      </p:sp>
+      <p:sp>
+        <p:nvSpPr>
+          <p:cNvPr id="241" name="Полоса"/>
           <p:cNvSpPr/>
           <p:nvPr/>
         </p:nvSpPr>
@@ -7399,7 +7637,7 @@
       </p:sp>
       <p:sp>
         <p:nvSpPr>
-          <p:cNvPr id="235" name="Номер 7"/>
+          <p:cNvPr id="242" name="Номер 7"/>
           <p:cNvSpPr/>
           <p:nvPr/>
         </p:nvSpPr>
@@ -7437,14 +7675,14 @@
       </p:sp>
       <p:sp>
         <p:nvSpPr>
-          <p:cNvPr id="236" name="Текст"/>
+          <p:cNvPr id="243" name="Текст"/>
           <p:cNvSpPr txBox="1"/>
           <p:nvPr/>
         </p:nvSpPr>
         <p:spPr>
           <a:xfrm>
-            <a:off x="2148840" y="6080760"/>
-            <a:ext cx="6035040" cy="566928"/>
+            <a:off x="2011680" y="6080760"/>
+            <a:ext cx="5029200" cy="566928"/>
           </a:xfrm>
           <a:prstGeom prst="rect">
             <a:avLst/>
@@ -7458,7 +7696,7 @@
           <a:lstStyle/>
           <a:p>
             <a:r>
-              <a:rPr sz="1650" b="1">
+              <a:rPr sz="1500" b="1">
                 <a:solidFill>
                   <a:srgbClr val="062D3F"/>
                 </a:solidFill>
@@ -7471,14 +7709,14 @@
       </p:sp>
       <p:sp>
         <p:nvSpPr>
-          <p:cNvPr id="237" name="Текст"/>
+          <p:cNvPr id="244" name="Текст"/>
           <p:cNvSpPr txBox="1"/>
           <p:nvPr/>
         </p:nvSpPr>
         <p:spPr>
           <a:xfrm>
-            <a:off x="8412480" y="6080760"/>
-            <a:ext cx="3566160" cy="566928"/>
+            <a:off x="7178040" y="6080760"/>
+            <a:ext cx="2743200" cy="566928"/>
           </a:xfrm>
           <a:prstGeom prst="rect">
             <a:avLst/>
@@ -7492,7 +7730,7 @@
           <a:lstStyle/>
           <a:p>
             <a:r>
-              <a:rPr sz="1600" b="0">
+              <a:rPr sz="1400" b="0">
                 <a:solidFill>
                   <a:srgbClr val="062D3F"/>
                 </a:solidFill>
@@ -7505,14 +7743,14 @@
       </p:sp>
       <p:sp>
         <p:nvSpPr>
-          <p:cNvPr id="238" name="Текст"/>
+          <p:cNvPr id="245" name="Текст"/>
           <p:cNvSpPr txBox="1"/>
           <p:nvPr/>
         </p:nvSpPr>
         <p:spPr>
           <a:xfrm>
-            <a:off x="12252960" y="6080760"/>
-            <a:ext cx="5303520" cy="566928"/>
+            <a:off x="10058400" y="6080760"/>
+            <a:ext cx="3657600" cy="566928"/>
           </a:xfrm>
           <a:prstGeom prst="rect">
             <a:avLst/>
@@ -7526,7 +7764,7 @@
           <a:lstStyle/>
           <a:p>
             <a:r>
-              <a:rPr sz="1600" b="0">
+              <a:rPr sz="1400" b="0">
                 <a:solidFill>
                   <a:srgbClr val="062D3F"/>
                 </a:solidFill>
@@ -7539,7 +7777,41 @@
       </p:sp>
       <p:sp>
         <p:nvSpPr>
-          <p:cNvPr id="239" name="Номер 8"/>
+          <p:cNvPr id="246" name="Текст"/>
+          <p:cNvSpPr txBox="1"/>
+          <p:nvPr/>
+        </p:nvSpPr>
+        <p:spPr>
+          <a:xfrm>
+            <a:off x="13853160" y="6080760"/>
+            <a:ext cx="4023360" cy="566928"/>
+          </a:xfrm>
+          <a:prstGeom prst="rect">
+            <a:avLst/>
+          </a:prstGeom>
+          <a:noFill/>
+        </p:spPr>
+        <p:txBody>
+          <a:bodyPr wrap="square" anchor="ctr" lIns="0" rIns="0" tIns="0" bIns="0">
+            <a:spAutoFit/>
+          </a:bodyPr>
+          <a:lstStyle/>
+          <a:p>
+            <a:r>
+              <a:rPr sz="1400" b="0">
+                <a:solidFill>
+                  <a:srgbClr val="062D3F"/>
+                </a:solidFill>
+                <a:latin typeface="Circe"/>
+              </a:rPr>
+              <a:t>Росстат по региону, стратегия региона</a:t>
+            </a:r>
+          </a:p>
+        </p:txBody>
+      </p:sp>
+      <p:sp>
+        <p:nvSpPr>
+          <p:cNvPr id="247" name="Номер 8"/>
           <p:cNvSpPr/>
           <p:nvPr/>
         </p:nvSpPr>
@@ -7577,14 +7849,14 @@
       </p:sp>
       <p:sp>
         <p:nvSpPr>
-          <p:cNvPr id="240" name="Текст"/>
+          <p:cNvPr id="248" name="Текст"/>
           <p:cNvSpPr txBox="1"/>
           <p:nvPr/>
         </p:nvSpPr>
         <p:spPr>
           <a:xfrm>
-            <a:off x="2148840" y="6647688"/>
-            <a:ext cx="6035040" cy="566928"/>
+            <a:off x="2011680" y="6647688"/>
+            <a:ext cx="5029200" cy="566928"/>
           </a:xfrm>
           <a:prstGeom prst="rect">
             <a:avLst/>
@@ -7598,7 +7870,7 @@
           <a:lstStyle/>
           <a:p>
             <a:r>
-              <a:rPr sz="1650" b="1">
+              <a:rPr sz="1500" b="1">
                 <a:solidFill>
                   <a:srgbClr val="062D3F"/>
                 </a:solidFill>
@@ -7611,14 +7883,14 @@
       </p:sp>
       <p:sp>
         <p:nvSpPr>
-          <p:cNvPr id="241" name="Текст"/>
+          <p:cNvPr id="249" name="Текст"/>
           <p:cNvSpPr txBox="1"/>
           <p:nvPr/>
         </p:nvSpPr>
         <p:spPr>
           <a:xfrm>
-            <a:off x="8412480" y="6647688"/>
-            <a:ext cx="3566160" cy="566928"/>
+            <a:off x="7178040" y="6647688"/>
+            <a:ext cx="2743200" cy="566928"/>
           </a:xfrm>
           <a:prstGeom prst="rect">
             <a:avLst/>
@@ -7632,7 +7904,7 @@
           <a:lstStyle/>
           <a:p>
             <a:r>
-              <a:rPr sz="1600" b="0">
+              <a:rPr sz="1400" b="0">
                 <a:solidFill>
                   <a:srgbClr val="062D3F"/>
                 </a:solidFill>
@@ -7645,14 +7917,14 @@
       </p:sp>
       <p:sp>
         <p:nvSpPr>
-          <p:cNvPr id="242" name="Текст"/>
+          <p:cNvPr id="250" name="Текст"/>
           <p:cNvSpPr txBox="1"/>
           <p:nvPr/>
         </p:nvSpPr>
         <p:spPr>
           <a:xfrm>
-            <a:off x="12252960" y="6647688"/>
-            <a:ext cx="5303520" cy="566928"/>
+            <a:off x="10058400" y="6647688"/>
+            <a:ext cx="3657600" cy="566928"/>
           </a:xfrm>
           <a:prstGeom prst="rect">
             <a:avLst/>
@@ -7666,7 +7938,7 @@
           <a:lstStyle/>
           <a:p>
             <a:r>
-              <a:rPr sz="1600" b="0">
+              <a:rPr sz="1400" b="0">
                 <a:solidFill>
                   <a:srgbClr val="062D3F"/>
                 </a:solidFill>
@@ -7679,7 +7951,41 @@
       </p:sp>
       <p:sp>
         <p:nvSpPr>
-          <p:cNvPr id="243" name="Полоса"/>
+          <p:cNvPr id="251" name="Текст"/>
+          <p:cNvSpPr txBox="1"/>
+          <p:nvPr/>
+        </p:nvSpPr>
+        <p:spPr>
+          <a:xfrm>
+            <a:off x="13853160" y="6647688"/>
+            <a:ext cx="4023360" cy="566928"/>
+          </a:xfrm>
+          <a:prstGeom prst="rect">
+            <a:avLst/>
+          </a:prstGeom>
+          <a:noFill/>
+        </p:spPr>
+        <p:txBody>
+          <a:bodyPr wrap="square" anchor="ctr" lIns="0" rIns="0" tIns="0" bIns="0">
+            <a:spAutoFit/>
+          </a:bodyPr>
+          <a:lstStyle/>
+          <a:p>
+            <a:r>
+              <a:rPr sz="1400" b="0">
+                <a:solidFill>
+                  <a:srgbClr val="062D3F"/>
+                </a:solidFill>
+                <a:latin typeface="Circe"/>
+              </a:rPr>
+              <a:t>БД ПМО, стратегия СЭР</a:t>
+            </a:r>
+          </a:p>
+        </p:txBody>
+      </p:sp>
+      <p:sp>
+        <p:nvSpPr>
+          <p:cNvPr id="252" name="Полоса"/>
           <p:cNvSpPr/>
           <p:nvPr/>
         </p:nvSpPr>
@@ -7710,7 +8016,7 @@
       </p:sp>
       <p:sp>
         <p:nvSpPr>
-          <p:cNvPr id="244" name="Номер 9"/>
+          <p:cNvPr id="253" name="Номер 9"/>
           <p:cNvSpPr/>
           <p:nvPr/>
         </p:nvSpPr>
@@ -7748,14 +8054,14 @@
       </p:sp>
       <p:sp>
         <p:nvSpPr>
-          <p:cNvPr id="245" name="Текст"/>
+          <p:cNvPr id="254" name="Текст"/>
           <p:cNvSpPr txBox="1"/>
           <p:nvPr/>
         </p:nvSpPr>
         <p:spPr>
           <a:xfrm>
-            <a:off x="2148840" y="7214616"/>
-            <a:ext cx="6035040" cy="566928"/>
+            <a:off x="2011680" y="7214616"/>
+            <a:ext cx="5029200" cy="566928"/>
           </a:xfrm>
           <a:prstGeom prst="rect">
             <a:avLst/>
@@ -7769,7 +8075,7 @@
           <a:lstStyle/>
           <a:p>
             <a:r>
-              <a:rPr sz="1650" b="1">
+              <a:rPr sz="1500" b="1">
                 <a:solidFill>
                   <a:srgbClr val="062D3F"/>
                 </a:solidFill>
@@ -7782,14 +8088,14 @@
       </p:sp>
       <p:sp>
         <p:nvSpPr>
-          <p:cNvPr id="246" name="Текст"/>
+          <p:cNvPr id="255" name="Текст"/>
           <p:cNvSpPr txBox="1"/>
           <p:nvPr/>
         </p:nvSpPr>
         <p:spPr>
           <a:xfrm>
-            <a:off x="8412480" y="7214616"/>
-            <a:ext cx="3566160" cy="566928"/>
+            <a:off x="7178040" y="7214616"/>
+            <a:ext cx="2743200" cy="566928"/>
           </a:xfrm>
           <a:prstGeom prst="rect">
             <a:avLst/>
@@ -7803,7 +8109,7 @@
           <a:lstStyle/>
           <a:p>
             <a:r>
-              <a:rPr sz="1600" b="0">
+              <a:rPr sz="1400" b="0">
                 <a:solidFill>
                   <a:srgbClr val="062D3F"/>
                 </a:solidFill>
@@ -7816,14 +8122,14 @@
       </p:sp>
       <p:sp>
         <p:nvSpPr>
-          <p:cNvPr id="247" name="Текст"/>
+          <p:cNvPr id="256" name="Текст"/>
           <p:cNvSpPr txBox="1"/>
           <p:nvPr/>
         </p:nvSpPr>
         <p:spPr>
           <a:xfrm>
-            <a:off x="12252960" y="7214616"/>
-            <a:ext cx="5303520" cy="566928"/>
+            <a:off x="10058400" y="7214616"/>
+            <a:ext cx="3657600" cy="566928"/>
           </a:xfrm>
           <a:prstGeom prst="rect">
             <a:avLst/>
@@ -7837,7 +8143,7 @@
           <a:lstStyle/>
           <a:p>
             <a:r>
-              <a:rPr sz="1600" b="0">
+              <a:rPr sz="1400" b="0">
                 <a:solidFill>
                   <a:srgbClr val="062D3F"/>
                 </a:solidFill>
@@ -7850,7 +8156,41 @@
       </p:sp>
       <p:sp>
         <p:nvSpPr>
-          <p:cNvPr id="248" name="Номер 10"/>
+          <p:cNvPr id="257" name="Текст"/>
+          <p:cNvSpPr txBox="1"/>
+          <p:nvPr/>
+        </p:nvSpPr>
+        <p:spPr>
+          <a:xfrm>
+            <a:off x="13853160" y="7214616"/>
+            <a:ext cx="4023360" cy="566928"/>
+          </a:xfrm>
+          <a:prstGeom prst="rect">
+            <a:avLst/>
+          </a:prstGeom>
+          <a:noFill/>
+        </p:spPr>
+        <p:txBody>
+          <a:bodyPr wrap="square" anchor="ctr" lIns="0" rIns="0" tIns="0" bIns="0">
+            <a:spAutoFit/>
+          </a:bodyPr>
+          <a:lstStyle/>
+          <a:p>
+            <a:r>
+              <a:rPr sz="1400" b="0">
+                <a:solidFill>
+                  <a:srgbClr val="062D3F"/>
+                </a:solidFill>
+                <a:latin typeface="Circe"/>
+              </a:rPr>
+              <a:t>БД ПМО, стратегия СЭР</a:t>
+            </a:r>
+          </a:p>
+        </p:txBody>
+      </p:sp>
+      <p:sp>
+        <p:nvSpPr>
+          <p:cNvPr id="258" name="Номер 10"/>
           <p:cNvSpPr/>
           <p:nvPr/>
         </p:nvSpPr>
@@ -7888,14 +8228,14 @@
       </p:sp>
       <p:sp>
         <p:nvSpPr>
-          <p:cNvPr id="249" name="Текст"/>
+          <p:cNvPr id="259" name="Текст"/>
           <p:cNvSpPr txBox="1"/>
           <p:nvPr/>
         </p:nvSpPr>
         <p:spPr>
           <a:xfrm>
-            <a:off x="2148840" y="7781544"/>
-            <a:ext cx="6035040" cy="566928"/>
+            <a:off x="2011680" y="7781544"/>
+            <a:ext cx="5029200" cy="566928"/>
           </a:xfrm>
           <a:prstGeom prst="rect">
             <a:avLst/>
@@ -7909,7 +8249,7 @@
           <a:lstStyle/>
           <a:p>
             <a:r>
-              <a:rPr sz="1650" b="1">
+              <a:rPr sz="1500" b="1">
                 <a:solidFill>
                   <a:srgbClr val="062D3F"/>
                 </a:solidFill>
@@ -7922,14 +8262,14 @@
       </p:sp>
       <p:sp>
         <p:nvSpPr>
-          <p:cNvPr id="250" name="Текст"/>
+          <p:cNvPr id="260" name="Текст"/>
           <p:cNvSpPr txBox="1"/>
           <p:nvPr/>
         </p:nvSpPr>
         <p:spPr>
           <a:xfrm>
-            <a:off x="8412480" y="7781544"/>
-            <a:ext cx="3566160" cy="566928"/>
+            <a:off x="7178040" y="7781544"/>
+            <a:ext cx="2743200" cy="566928"/>
           </a:xfrm>
           <a:prstGeom prst="rect">
             <a:avLst/>
@@ -7943,7 +8283,7 @@
           <a:lstStyle/>
           <a:p>
             <a:r>
-              <a:rPr sz="1600" b="0">
+              <a:rPr sz="1400" b="0">
                 <a:solidFill>
                   <a:srgbClr val="062D3F"/>
                 </a:solidFill>
@@ -7956,14 +8296,14 @@
       </p:sp>
       <p:sp>
         <p:nvSpPr>
-          <p:cNvPr id="251" name="Текст"/>
+          <p:cNvPr id="261" name="Текст"/>
           <p:cNvSpPr txBox="1"/>
           <p:nvPr/>
         </p:nvSpPr>
         <p:spPr>
           <a:xfrm>
-            <a:off x="12252960" y="7781544"/>
-            <a:ext cx="5303520" cy="566928"/>
+            <a:off x="10058400" y="7781544"/>
+            <a:ext cx="3657600" cy="566928"/>
           </a:xfrm>
           <a:prstGeom prst="rect">
             <a:avLst/>
@@ -7977,7 +8317,7 @@
           <a:lstStyle/>
           <a:p>
             <a:r>
-              <a:rPr sz="1600" b="0">
+              <a:rPr sz="1400" b="0">
                 <a:solidFill>
                   <a:srgbClr val="062D3F"/>
                 </a:solidFill>
@@ -7990,7 +8330,41 @@
       </p:sp>
       <p:sp>
         <p:nvSpPr>
-          <p:cNvPr id="252" name="Полоса"/>
+          <p:cNvPr id="262" name="Текст"/>
+          <p:cNvSpPr txBox="1"/>
+          <p:nvPr/>
+        </p:nvSpPr>
+        <p:spPr>
+          <a:xfrm>
+            <a:off x="13853160" y="7781544"/>
+            <a:ext cx="4023360" cy="566928"/>
+          </a:xfrm>
+          <a:prstGeom prst="rect">
+            <a:avLst/>
+          </a:prstGeom>
+          <a:noFill/>
+        </p:spPr>
+        <p:txBody>
+          <a:bodyPr wrap="square" anchor="ctr" lIns="0" rIns="0" tIns="0" bIns="0">
+            <a:spAutoFit/>
+          </a:bodyPr>
+          <a:lstStyle/>
+          <a:p>
+            <a:r>
+              <a:rPr sz="1400" b="0">
+                <a:solidFill>
+                  <a:srgbClr val="062D3F"/>
+                </a:solidFill>
+                <a:latin typeface="Circe"/>
+              </a:rPr>
+              <a:t>Региональный Росстат, итоги ВПН-2020</a:t>
+            </a:r>
+          </a:p>
+        </p:txBody>
+      </p:sp>
+      <p:sp>
+        <p:nvSpPr>
+          <p:cNvPr id="263" name="Полоса"/>
           <p:cNvSpPr/>
           <p:nvPr/>
         </p:nvSpPr>
@@ -8021,7 +8395,7 @@
       </p:sp>
       <p:sp>
         <p:nvSpPr>
-          <p:cNvPr id="253" name="Номер 11"/>
+          <p:cNvPr id="264" name="Номер 11"/>
           <p:cNvSpPr/>
           <p:nvPr/>
         </p:nvSpPr>
@@ -8059,14 +8433,14 @@
       </p:sp>
       <p:sp>
         <p:nvSpPr>
-          <p:cNvPr id="254" name="Текст"/>
+          <p:cNvPr id="265" name="Текст"/>
           <p:cNvSpPr txBox="1"/>
           <p:nvPr/>
         </p:nvSpPr>
         <p:spPr>
           <a:xfrm>
-            <a:off x="2148840" y="8348471"/>
-            <a:ext cx="6035040" cy="566928"/>
+            <a:off x="2011680" y="8348471"/>
+            <a:ext cx="5029200" cy="566928"/>
           </a:xfrm>
           <a:prstGeom prst="rect">
             <a:avLst/>
@@ -8080,7 +8454,7 @@
           <a:lstStyle/>
           <a:p>
             <a:r>
-              <a:rPr sz="1650" b="1">
+              <a:rPr sz="1500" b="1">
                 <a:solidFill>
                   <a:srgbClr val="062D3F"/>
                 </a:solidFill>
@@ -8093,14 +8467,14 @@
       </p:sp>
       <p:sp>
         <p:nvSpPr>
-          <p:cNvPr id="255" name="Текст"/>
+          <p:cNvPr id="266" name="Текст"/>
           <p:cNvSpPr txBox="1"/>
           <p:nvPr/>
         </p:nvSpPr>
         <p:spPr>
           <a:xfrm>
-            <a:off x="8412480" y="8348471"/>
-            <a:ext cx="3566160" cy="566928"/>
+            <a:off x="7178040" y="8348471"/>
+            <a:ext cx="2743200" cy="566928"/>
           </a:xfrm>
           <a:prstGeom prst="rect">
             <a:avLst/>
@@ -8114,7 +8488,7 @@
           <a:lstStyle/>
           <a:p>
             <a:r>
-              <a:rPr sz="1600" b="0">
+              <a:rPr sz="1400" b="0">
                 <a:solidFill>
                   <a:srgbClr val="062D3F"/>
                 </a:solidFill>
@@ -8127,14 +8501,14 @@
       </p:sp>
       <p:sp>
         <p:nvSpPr>
-          <p:cNvPr id="256" name="Текст"/>
+          <p:cNvPr id="267" name="Текст"/>
           <p:cNvSpPr txBox="1"/>
           <p:nvPr/>
         </p:nvSpPr>
         <p:spPr>
           <a:xfrm>
-            <a:off x="12252960" y="8348471"/>
-            <a:ext cx="5303520" cy="566928"/>
+            <a:off x="10058400" y="8348471"/>
+            <a:ext cx="3657600" cy="566928"/>
           </a:xfrm>
           <a:prstGeom prst="rect">
             <a:avLst/>
@@ -8148,7 +8522,7 @@
           <a:lstStyle/>
           <a:p>
             <a:r>
-              <a:rPr sz="1600" b="0">
+              <a:rPr sz="1400" b="0">
                 <a:solidFill>
                   <a:srgbClr val="062D3F"/>
                 </a:solidFill>
@@ -8161,7 +8535,41 @@
       </p:sp>
       <p:sp>
         <p:nvSpPr>
-          <p:cNvPr id="257" name="Номер 12"/>
+          <p:cNvPr id="268" name="Текст"/>
+          <p:cNvSpPr txBox="1"/>
+          <p:nvPr/>
+        </p:nvSpPr>
+        <p:spPr>
+          <a:xfrm>
+            <a:off x="13853160" y="8348471"/>
+            <a:ext cx="4023360" cy="566928"/>
+          </a:xfrm>
+          <a:prstGeom prst="rect">
+            <a:avLst/>
+          </a:prstGeom>
+          <a:noFill/>
+        </p:spPr>
+        <p:txBody>
+          <a:bodyPr wrap="square" anchor="ctr" lIns="0" rIns="0" tIns="0" bIns="0">
+            <a:spAutoFit/>
+          </a:bodyPr>
+          <a:lstStyle/>
+          <a:p>
+            <a:r>
+              <a:rPr sz="1400" b="0">
+                <a:solidFill>
+                  <a:srgbClr val="062D3F"/>
+                </a:solidFill>
+                <a:latin typeface="Circe"/>
+              </a:rPr>
+              <a:t>Расчёт по половозрастной структуре</a:t>
+            </a:r>
+          </a:p>
+        </p:txBody>
+      </p:sp>
+      <p:sp>
+        <p:nvSpPr>
+          <p:cNvPr id="269" name="Номер 12"/>
           <p:cNvSpPr/>
           <p:nvPr/>
         </p:nvSpPr>
@@ -8199,14 +8607,14 @@
       </p:sp>
       <p:sp>
         <p:nvSpPr>
-          <p:cNvPr id="258" name="Текст"/>
+          <p:cNvPr id="270" name="Текст"/>
           <p:cNvSpPr txBox="1"/>
           <p:nvPr/>
         </p:nvSpPr>
         <p:spPr>
           <a:xfrm>
-            <a:off x="2148840" y="8915399"/>
-            <a:ext cx="6035040" cy="566928"/>
+            <a:off x="2011680" y="8915399"/>
+            <a:ext cx="5029200" cy="566928"/>
           </a:xfrm>
           <a:prstGeom prst="rect">
             <a:avLst/>
@@ -8220,7 +8628,7 @@
           <a:lstStyle/>
           <a:p>
             <a:r>
-              <a:rPr sz="1650" b="1">
+              <a:rPr sz="1500" b="1">
                 <a:solidFill>
                   <a:srgbClr val="062D3F"/>
                 </a:solidFill>
@@ -8233,14 +8641,14 @@
       </p:sp>
       <p:sp>
         <p:nvSpPr>
-          <p:cNvPr id="259" name="Текст"/>
+          <p:cNvPr id="271" name="Текст"/>
           <p:cNvSpPr txBox="1"/>
           <p:nvPr/>
         </p:nvSpPr>
         <p:spPr>
           <a:xfrm>
-            <a:off x="8412480" y="8915399"/>
-            <a:ext cx="3566160" cy="566928"/>
+            <a:off x="7178040" y="8915399"/>
+            <a:ext cx="2743200" cy="566928"/>
           </a:xfrm>
           <a:prstGeom prst="rect">
             <a:avLst/>
@@ -8254,7 +8662,7 @@
           <a:lstStyle/>
           <a:p>
             <a:r>
-              <a:rPr sz="1600" b="0">
+              <a:rPr sz="1400" b="0">
                 <a:solidFill>
                   <a:srgbClr val="062D3F"/>
                 </a:solidFill>
@@ -8267,14 +8675,14 @@
       </p:sp>
       <p:sp>
         <p:nvSpPr>
-          <p:cNvPr id="260" name="Текст"/>
+          <p:cNvPr id="272" name="Текст"/>
           <p:cNvSpPr txBox="1"/>
           <p:nvPr/>
         </p:nvSpPr>
         <p:spPr>
           <a:xfrm>
-            <a:off x="12252960" y="8915399"/>
-            <a:ext cx="5303520" cy="566928"/>
+            <a:off x="10058400" y="8915399"/>
+            <a:ext cx="3657600" cy="566928"/>
           </a:xfrm>
           <a:prstGeom prst="rect">
             <a:avLst/>
@@ -8288,13 +8696,47 @@
           <a:lstStyle/>
           <a:p>
             <a:r>
-              <a:rPr sz="1600" b="0">
+              <a:rPr sz="1400" b="0">
                 <a:solidFill>
                   <a:srgbClr val="062D3F"/>
                 </a:solidFill>
                 <a:latin typeface="Circe"/>
               </a:rPr>
               <a:t>Нагрузка пожилыми и детьми</a:t>
+            </a:r>
+          </a:p>
+        </p:txBody>
+      </p:sp>
+      <p:sp>
+        <p:nvSpPr>
+          <p:cNvPr id="273" name="Текст"/>
+          <p:cNvSpPr txBox="1"/>
+          <p:nvPr/>
+        </p:nvSpPr>
+        <p:spPr>
+          <a:xfrm>
+            <a:off x="13853160" y="8915399"/>
+            <a:ext cx="4023360" cy="566928"/>
+          </a:xfrm>
+          <a:prstGeom prst="rect">
+            <a:avLst/>
+          </a:prstGeom>
+          <a:noFill/>
+        </p:spPr>
+        <p:txBody>
+          <a:bodyPr wrap="square" anchor="ctr" lIns="0" rIns="0" tIns="0" bIns="0">
+            <a:spAutoFit/>
+          </a:bodyPr>
+          <a:lstStyle/>
+          <a:p>
+            <a:r>
+              <a:rPr sz="1400" b="0">
+                <a:solidFill>
+                  <a:srgbClr val="062D3F"/>
+                </a:solidFill>
+                <a:latin typeface="Circe"/>
+              </a:rPr>
+              <a:t>Расчёт по половозрастной структуре</a:t>
             </a:r>
           </a:p>
         </p:txBody>

</xml_diff>